<commit_message>
Convert presentation to 16:9 widescreen (13.33 × 7.5 in)
- Set slide size via xml_set_attr on sldSz cx=12192000 / type=screen16x9
- Rescaled all x-positions and widths by ×1.333 (4:3 → 16:9)
- Slide backgrounds now cover the full 13.33 in width
- All 11 slides rebuild cleanly; slide size confirmed 13.33 × 7.5 in

Co-Authored-By: Claude Sonnet 4.6 <noreply@anthropic.com>
</commit_message>
<xml_diff>
--- a/docs/MIP_MMA_PPE_apresentacao.pptx
+++ b/docs/MIP_MMA_PPE_apresentacao.pptx
@@ -17,7 +17,7 @@
     <p:sldId id="265" r:id="rId17"/>
     <p:sldId id="266" r:id="rId18"/>
   </p:sldIdLst>
-  <p:sldSz cx="9144000" cy="6858000" type="screen4x3"/>
+  <p:sldSz cx="12192000" cy="6858000" type="screen16x9"/>
   <p:notesSz cx="6858000" cy="9144000"/>
   <p:custDataLst>
     <p:tags r:id="rId3"/>
@@ -2237,7 +2237,7 @@
         <p:spPr>
           <a:xfrm>
             <a:off x="0" y="0"/>
-            <a:ext cx="9144000" cy="6858000"/>
+            <a:ext cx="12192000" cy="6858000"/>
           </a:xfrm>
           <a:solidFill>
             <a:srgbClr val="1C2B4A">
@@ -2276,7 +2276,7 @@
         </p:nvSpPr>
         <p:spPr>
           <a:xfrm>
-            <a:off x="347472" y="1417320"/>
+            <a:off x="429768" y="1417320"/>
             <a:ext cx="64008" cy="3931920"/>
           </a:xfrm>
           <a:solidFill>
@@ -2316,8 +2316,8 @@
         </p:nvSpPr>
         <p:spPr>
           <a:xfrm>
-            <a:off x="640080" y="1417320"/>
-            <a:ext cx="8229600" cy="1005840"/>
+            <a:off x="850392" y="1417320"/>
+            <a:ext cx="10972800" cy="1005840"/>
           </a:xfrm>
         </p:spPr>
         <p:txBody>
@@ -2365,8 +2365,8 @@
         </p:nvSpPr>
         <p:spPr>
           <a:xfrm>
-            <a:off x="640080" y="2514600"/>
-            <a:ext cx="7772400" cy="1371600"/>
+            <a:off x="850392" y="2514600"/>
+            <a:ext cx="10515600" cy="1371600"/>
           </a:xfrm>
         </p:spPr>
         <p:txBody>
@@ -2415,8 +2415,8 @@
         </p:nvSpPr>
         <p:spPr>
           <a:xfrm>
-            <a:off x="640080" y="3977640"/>
-            <a:ext cx="8229600" cy="457200"/>
+            <a:off x="850392" y="3977640"/>
+            <a:ext cx="10972800" cy="457200"/>
           </a:xfrm>
         </p:spPr>
         <p:txBody>
@@ -2464,8 +2464,8 @@
         </p:nvSpPr>
         <p:spPr>
           <a:xfrm>
-            <a:off x="640080" y="5852160"/>
-            <a:ext cx="4572000" cy="365760"/>
+            <a:off x="850392" y="5852160"/>
+            <a:ext cx="5486400" cy="365760"/>
           </a:xfrm>
         </p:spPr>
         <p:txBody>
@@ -2513,8 +2513,8 @@
         </p:nvSpPr>
         <p:spPr>
           <a:xfrm>
-            <a:off x="4572000" y="5852160"/>
-            <a:ext cx="4297680" cy="365760"/>
+            <a:off x="6400800" y="5852160"/>
+            <a:ext cx="5486400" cy="365760"/>
           </a:xfrm>
         </p:spPr>
         <p:txBody>
@@ -2588,7 +2588,7 @@
         <p:spPr>
           <a:xfrm>
             <a:off x="0" y="0"/>
-            <a:ext cx="9144000" cy="6858000"/>
+            <a:ext cx="12192000" cy="6858000"/>
           </a:xfrm>
           <a:solidFill>
             <a:srgbClr val="1C2B4A">
@@ -2628,7 +2628,7 @@
         <p:spPr>
           <a:xfrm>
             <a:off x="0" y="0"/>
-            <a:ext cx="9144000" cy="822960"/>
+            <a:ext cx="12192000" cy="822960"/>
           </a:xfrm>
           <a:solidFill>
             <a:srgbClr val="F39C12">
@@ -2667,8 +2667,8 @@
         </p:nvSpPr>
         <p:spPr>
           <a:xfrm>
-            <a:off x="365760" y="91440"/>
-            <a:ext cx="8229600" cy="640080"/>
+            <a:off x="457200" y="91440"/>
+            <a:ext cx="11277600" cy="640080"/>
           </a:xfrm>
         </p:spPr>
         <p:txBody>
@@ -2716,8 +2716,8 @@
         </p:nvSpPr>
         <p:spPr>
           <a:xfrm>
-            <a:off x="182880" y="914400"/>
-            <a:ext cx="4297680" cy="5715000"/>
+            <a:off x="246888" y="914400"/>
+            <a:ext cx="5733288" cy="5715000"/>
           </a:xfrm>
           <a:solidFill>
             <a:srgbClr val="1A2840">
@@ -2756,8 +2756,8 @@
         </p:nvSpPr>
         <p:spPr>
           <a:xfrm>
-            <a:off x="365760" y="987552"/>
-            <a:ext cx="3931920" cy="411480"/>
+            <a:off x="493776" y="987552"/>
+            <a:ext cx="5239512" cy="411480"/>
           </a:xfrm>
         </p:spPr>
         <p:txBody>
@@ -2805,8 +2805,8 @@
         </p:nvSpPr>
         <p:spPr>
           <a:xfrm>
-            <a:off x="411480" y="1508760"/>
-            <a:ext cx="3840480" cy="320040"/>
+            <a:off x="548640" y="1508760"/>
+            <a:ext cx="5120640" cy="320040"/>
           </a:xfrm>
         </p:spPr>
         <p:txBody>
@@ -2854,8 +2854,8 @@
         </p:nvSpPr>
         <p:spPr>
           <a:xfrm>
-            <a:off x="411480" y="1810512"/>
-            <a:ext cx="3840480" cy="640080"/>
+            <a:off x="548640" y="1810512"/>
+            <a:ext cx="5120640" cy="640080"/>
           </a:xfrm>
         </p:spPr>
         <p:txBody>
@@ -2903,8 +2903,8 @@
         </p:nvSpPr>
         <p:spPr>
           <a:xfrm>
-            <a:off x="411480" y="2514600"/>
-            <a:ext cx="3840480" cy="320040"/>
+            <a:off x="548640" y="2514600"/>
+            <a:ext cx="5120640" cy="320040"/>
           </a:xfrm>
         </p:spPr>
         <p:txBody>
@@ -2952,8 +2952,8 @@
         </p:nvSpPr>
         <p:spPr>
           <a:xfrm>
-            <a:off x="411480" y="2816352"/>
-            <a:ext cx="3840480" cy="640080"/>
+            <a:off x="548640" y="2816352"/>
+            <a:ext cx="5120640" cy="640080"/>
           </a:xfrm>
         </p:spPr>
         <p:txBody>
@@ -3001,8 +3001,8 @@
         </p:nvSpPr>
         <p:spPr>
           <a:xfrm>
-            <a:off x="411480" y="3520440"/>
-            <a:ext cx="3840480" cy="320040"/>
+            <a:off x="548640" y="3520440"/>
+            <a:ext cx="5120640" cy="320040"/>
           </a:xfrm>
         </p:spPr>
         <p:txBody>
@@ -3050,8 +3050,8 @@
         </p:nvSpPr>
         <p:spPr>
           <a:xfrm>
-            <a:off x="411480" y="3822192"/>
-            <a:ext cx="3840480" cy="640080"/>
+            <a:off x="548640" y="3822192"/>
+            <a:ext cx="5120640" cy="640080"/>
           </a:xfrm>
         </p:spPr>
         <p:txBody>
@@ -3099,8 +3099,8 @@
         </p:nvSpPr>
         <p:spPr>
           <a:xfrm>
-            <a:off x="411480" y="4526280"/>
-            <a:ext cx="3840480" cy="320040"/>
+            <a:off x="548640" y="4526280"/>
+            <a:ext cx="5120640" cy="320040"/>
           </a:xfrm>
         </p:spPr>
         <p:txBody>
@@ -3148,8 +3148,8 @@
         </p:nvSpPr>
         <p:spPr>
           <a:xfrm>
-            <a:off x="411480" y="4828032"/>
-            <a:ext cx="3840480" cy="640080"/>
+            <a:off x="548640" y="4828032"/>
+            <a:ext cx="5120640" cy="640080"/>
           </a:xfrm>
         </p:spPr>
         <p:txBody>
@@ -3197,8 +3197,8 @@
         </p:nvSpPr>
         <p:spPr>
           <a:xfrm>
-            <a:off x="411480" y="5532120"/>
-            <a:ext cx="3840480" cy="320040"/>
+            <a:off x="548640" y="5532120"/>
+            <a:ext cx="5120640" cy="320040"/>
           </a:xfrm>
         </p:spPr>
         <p:txBody>
@@ -3246,8 +3246,8 @@
         </p:nvSpPr>
         <p:spPr>
           <a:xfrm>
-            <a:off x="411480" y="5833872"/>
-            <a:ext cx="3840480" cy="640080"/>
+            <a:off x="548640" y="5833872"/>
+            <a:ext cx="5120640" cy="640080"/>
           </a:xfrm>
         </p:spPr>
         <p:txBody>
@@ -3295,8 +3295,8 @@
         </p:nvSpPr>
         <p:spPr>
           <a:xfrm>
-            <a:off x="4663440" y="914400"/>
-            <a:ext cx="4297680" cy="5715000"/>
+            <a:off x="6217920" y="914400"/>
+            <a:ext cx="5733288" cy="5715000"/>
           </a:xfrm>
           <a:solidFill>
             <a:srgbClr val="1A2840">
@@ -3335,8 +3335,8 @@
         </p:nvSpPr>
         <p:spPr>
           <a:xfrm>
-            <a:off x="4846320" y="987552"/>
-            <a:ext cx="3931920" cy="411480"/>
+            <a:off x="6464808" y="987552"/>
+            <a:ext cx="5239512" cy="411480"/>
           </a:xfrm>
         </p:spPr>
         <p:txBody>
@@ -3384,8 +3384,8 @@
         </p:nvSpPr>
         <p:spPr>
           <a:xfrm>
-            <a:off x="4892040" y="1508760"/>
-            <a:ext cx="3840480" cy="320040"/>
+            <a:off x="6519672" y="1508760"/>
+            <a:ext cx="5120640" cy="320040"/>
           </a:xfrm>
         </p:spPr>
         <p:txBody>
@@ -3433,8 +3433,8 @@
         </p:nvSpPr>
         <p:spPr>
           <a:xfrm>
-            <a:off x="4892040" y="1810512"/>
-            <a:ext cx="3840480" cy="640080"/>
+            <a:off x="6519672" y="1810512"/>
+            <a:ext cx="5120640" cy="640080"/>
           </a:xfrm>
         </p:spPr>
         <p:txBody>
@@ -3482,8 +3482,8 @@
         </p:nvSpPr>
         <p:spPr>
           <a:xfrm>
-            <a:off x="4892040" y="2514600"/>
-            <a:ext cx="3840480" cy="320040"/>
+            <a:off x="6519672" y="2514600"/>
+            <a:ext cx="5120640" cy="320040"/>
           </a:xfrm>
         </p:spPr>
         <p:txBody>
@@ -3531,8 +3531,8 @@
         </p:nvSpPr>
         <p:spPr>
           <a:xfrm>
-            <a:off x="4892040" y="2816352"/>
-            <a:ext cx="3840480" cy="640080"/>
+            <a:off x="6519672" y="2816352"/>
+            <a:ext cx="5120640" cy="640080"/>
           </a:xfrm>
         </p:spPr>
         <p:txBody>
@@ -3580,8 +3580,8 @@
         </p:nvSpPr>
         <p:spPr>
           <a:xfrm>
-            <a:off x="4892040" y="3520440"/>
-            <a:ext cx="3840480" cy="320040"/>
+            <a:off x="6519672" y="3520440"/>
+            <a:ext cx="5120640" cy="320040"/>
           </a:xfrm>
         </p:spPr>
         <p:txBody>
@@ -3629,8 +3629,8 @@
         </p:nvSpPr>
         <p:spPr>
           <a:xfrm>
-            <a:off x="4892040" y="3822192"/>
-            <a:ext cx="3840480" cy="640080"/>
+            <a:off x="6519672" y="3822192"/>
+            <a:ext cx="5120640" cy="640080"/>
           </a:xfrm>
         </p:spPr>
         <p:txBody>
@@ -3678,8 +3678,8 @@
         </p:nvSpPr>
         <p:spPr>
           <a:xfrm>
-            <a:off x="4892040" y="4526280"/>
-            <a:ext cx="3840480" cy="320040"/>
+            <a:off x="6519672" y="4526280"/>
+            <a:ext cx="5120640" cy="320040"/>
           </a:xfrm>
         </p:spPr>
         <p:txBody>
@@ -3727,8 +3727,8 @@
         </p:nvSpPr>
         <p:spPr>
           <a:xfrm>
-            <a:off x="4892040" y="4828032"/>
-            <a:ext cx="3840480" cy="640080"/>
+            <a:off x="6519672" y="4828032"/>
+            <a:ext cx="5120640" cy="640080"/>
           </a:xfrm>
         </p:spPr>
         <p:txBody>
@@ -3776,8 +3776,8 @@
         </p:nvSpPr>
         <p:spPr>
           <a:xfrm>
-            <a:off x="4892040" y="5532120"/>
-            <a:ext cx="3840480" cy="320040"/>
+            <a:off x="6519672" y="5532120"/>
+            <a:ext cx="5120640" cy="320040"/>
           </a:xfrm>
         </p:spPr>
         <p:txBody>
@@ -3825,8 +3825,8 @@
         </p:nvSpPr>
         <p:spPr>
           <a:xfrm>
-            <a:off x="4892040" y="5833872"/>
-            <a:ext cx="3840480" cy="640080"/>
+            <a:off x="6519672" y="5833872"/>
+            <a:ext cx="5120640" cy="640080"/>
           </a:xfrm>
         </p:spPr>
         <p:txBody>
@@ -3900,7 +3900,7 @@
         <p:spPr>
           <a:xfrm>
             <a:off x="0" y="0"/>
-            <a:ext cx="9144000" cy="6858000"/>
+            <a:ext cx="12192000" cy="6858000"/>
           </a:xfrm>
           <a:solidFill>
             <a:srgbClr val="1C2B4A">
@@ -3939,7 +3939,7 @@
         </p:nvSpPr>
         <p:spPr>
           <a:xfrm>
-            <a:off x="320040" y="1828800"/>
+            <a:off x="429768" y="1828800"/>
             <a:ext cx="64008" cy="3200400"/>
           </a:xfrm>
           <a:solidFill>
@@ -3979,8 +3979,8 @@
         </p:nvSpPr>
         <p:spPr>
           <a:xfrm>
-            <a:off x="640080" y="1920240"/>
-            <a:ext cx="8229600" cy="914400"/>
+            <a:off x="850392" y="1920240"/>
+            <a:ext cx="10972800" cy="914400"/>
           </a:xfrm>
         </p:spPr>
         <p:txBody>
@@ -4028,8 +4028,8 @@
         </p:nvSpPr>
         <p:spPr>
           <a:xfrm>
-            <a:off x="640080" y="2926080"/>
-            <a:ext cx="7772400" cy="548640"/>
+            <a:off x="850392" y="2926080"/>
+            <a:ext cx="10515600" cy="548640"/>
           </a:xfrm>
         </p:spPr>
         <p:txBody>
@@ -4077,8 +4077,8 @@
         </p:nvSpPr>
         <p:spPr>
           <a:xfrm>
-            <a:off x="640080" y="3611880"/>
-            <a:ext cx="2651760" cy="411480"/>
+            <a:off x="850392" y="3611880"/>
+            <a:ext cx="3538728" cy="411480"/>
           </a:xfrm>
         </p:spPr>
         <p:txBody>
@@ -4126,8 +4126,8 @@
         </p:nvSpPr>
         <p:spPr>
           <a:xfrm>
-            <a:off x="3383280" y="3611880"/>
-            <a:ext cx="5394960" cy="411480"/>
+            <a:off x="4636008" y="3611880"/>
+            <a:ext cx="7196328" cy="411480"/>
           </a:xfrm>
         </p:spPr>
         <p:txBody>
@@ -4175,8 +4175,8 @@
         </p:nvSpPr>
         <p:spPr>
           <a:xfrm>
-            <a:off x="640080" y="4251960"/>
-            <a:ext cx="2651760" cy="411480"/>
+            <a:off x="850392" y="4251960"/>
+            <a:ext cx="3538728" cy="411480"/>
           </a:xfrm>
         </p:spPr>
         <p:txBody>
@@ -4224,8 +4224,8 @@
         </p:nvSpPr>
         <p:spPr>
           <a:xfrm>
-            <a:off x="3383280" y="4251960"/>
-            <a:ext cx="5394960" cy="411480"/>
+            <a:off x="4636008" y="4251960"/>
+            <a:ext cx="7196328" cy="411480"/>
           </a:xfrm>
         </p:spPr>
         <p:txBody>
@@ -4273,8 +4273,8 @@
         </p:nvSpPr>
         <p:spPr>
           <a:xfrm>
-            <a:off x="640080" y="4892040"/>
-            <a:ext cx="2651760" cy="411480"/>
+            <a:off x="850392" y="4892040"/>
+            <a:ext cx="3538728" cy="411480"/>
           </a:xfrm>
         </p:spPr>
         <p:txBody>
@@ -4322,8 +4322,8 @@
         </p:nvSpPr>
         <p:spPr>
           <a:xfrm>
-            <a:off x="3383280" y="4892040"/>
-            <a:ext cx="5394960" cy="411480"/>
+            <a:off x="4636008" y="4892040"/>
+            <a:ext cx="7196328" cy="411480"/>
           </a:xfrm>
         </p:spPr>
         <p:txBody>
@@ -4397,7 +4397,7 @@
         <p:spPr>
           <a:xfrm>
             <a:off x="0" y="0"/>
-            <a:ext cx="9144000" cy="6858000"/>
+            <a:ext cx="12192000" cy="6858000"/>
           </a:xfrm>
           <a:solidFill>
             <a:srgbClr val="1C2B4A">
@@ -4437,7 +4437,7 @@
         <p:spPr>
           <a:xfrm>
             <a:off x="0" y="0"/>
-            <a:ext cx="9144000" cy="822960"/>
+            <a:ext cx="12192000" cy="822960"/>
           </a:xfrm>
           <a:solidFill>
             <a:srgbClr val="1D9E75">
@@ -4476,8 +4476,8 @@
         </p:nvSpPr>
         <p:spPr>
           <a:xfrm>
-            <a:off x="365760" y="91440"/>
-            <a:ext cx="8229600" cy="640080"/>
+            <a:off x="457200" y="91440"/>
+            <a:ext cx="11277600" cy="640080"/>
           </a:xfrm>
         </p:spPr>
         <p:txBody>
@@ -4525,8 +4525,8 @@
         </p:nvSpPr>
         <p:spPr>
           <a:xfrm>
-            <a:off x="182880" y="960120"/>
-            <a:ext cx="2880360" cy="5212080"/>
+            <a:off x="246888" y="960120"/>
+            <a:ext cx="3840480" cy="5212080"/>
           </a:xfrm>
           <a:solidFill>
             <a:srgbClr val="1A2840">
@@ -4565,8 +4565,8 @@
         </p:nvSpPr>
         <p:spPr>
           <a:xfrm>
-            <a:off x="292608" y="1024128"/>
-            <a:ext cx="2651760" cy="54864"/>
+            <a:off x="393192" y="1024128"/>
+            <a:ext cx="3538728" cy="54864"/>
           </a:xfrm>
           <a:solidFill>
             <a:srgbClr val="F39C12">
@@ -4605,8 +4605,8 @@
         </p:nvSpPr>
         <p:spPr>
           <a:xfrm>
-            <a:off x="320040" y="1115568"/>
-            <a:ext cx="2651760" cy="502920"/>
+            <a:off x="429768" y="1115568"/>
+            <a:ext cx="3538728" cy="502920"/>
           </a:xfrm>
         </p:spPr>
         <p:txBody>
@@ -4654,8 +4654,8 @@
         </p:nvSpPr>
         <p:spPr>
           <a:xfrm>
-            <a:off x="320040" y="1664208"/>
-            <a:ext cx="2651760" cy="4297680"/>
+            <a:off x="429768" y="1664208"/>
+            <a:ext cx="3538728" cy="4297680"/>
           </a:xfrm>
         </p:spPr>
         <p:txBody>
@@ -4787,8 +4787,8 @@
         </p:nvSpPr>
         <p:spPr>
           <a:xfrm>
-            <a:off x="3172968" y="960120"/>
-            <a:ext cx="2880360" cy="5212080"/>
+            <a:off x="4233672" y="960120"/>
+            <a:ext cx="3840480" cy="5212080"/>
           </a:xfrm>
           <a:solidFill>
             <a:srgbClr val="1A2840">
@@ -4827,8 +4827,8 @@
         </p:nvSpPr>
         <p:spPr>
           <a:xfrm>
-            <a:off x="3282696" y="1024128"/>
-            <a:ext cx="2651760" cy="54864"/>
+            <a:off x="4379976" y="1024128"/>
+            <a:ext cx="3538728" cy="54864"/>
           </a:xfrm>
           <a:solidFill>
             <a:srgbClr val="378ADD">
@@ -4867,8 +4867,8 @@
         </p:nvSpPr>
         <p:spPr>
           <a:xfrm>
-            <a:off x="3310128" y="1115568"/>
-            <a:ext cx="2651760" cy="502920"/>
+            <a:off x="4416552" y="1115568"/>
+            <a:ext cx="3538728" cy="502920"/>
           </a:xfrm>
         </p:spPr>
         <p:txBody>
@@ -4916,8 +4916,8 @@
         </p:nvSpPr>
         <p:spPr>
           <a:xfrm>
-            <a:off x="3310128" y="1664208"/>
-            <a:ext cx="2651760" cy="4297680"/>
+            <a:off x="4416552" y="1664208"/>
+            <a:ext cx="3538728" cy="4297680"/>
           </a:xfrm>
         </p:spPr>
         <p:txBody>
@@ -5049,8 +5049,8 @@
         </p:nvSpPr>
         <p:spPr>
           <a:xfrm>
-            <a:off x="6163056" y="960120"/>
-            <a:ext cx="2880360" cy="5212080"/>
+            <a:off x="8220456" y="960120"/>
+            <a:ext cx="3840480" cy="5212080"/>
           </a:xfrm>
           <a:solidFill>
             <a:srgbClr val="1A2840">
@@ -5089,8 +5089,8 @@
         </p:nvSpPr>
         <p:spPr>
           <a:xfrm>
-            <a:off x="6272784" y="1024128"/>
-            <a:ext cx="2651760" cy="54864"/>
+            <a:off x="8366760" y="1024128"/>
+            <a:ext cx="3538728" cy="54864"/>
           </a:xfrm>
           <a:solidFill>
             <a:srgbClr val="1D9E75">
@@ -5129,8 +5129,8 @@
         </p:nvSpPr>
         <p:spPr>
           <a:xfrm>
-            <a:off x="6300216" y="1115568"/>
-            <a:ext cx="2651760" cy="502920"/>
+            <a:off x="8403336" y="1115568"/>
+            <a:ext cx="3538728" cy="502920"/>
           </a:xfrm>
         </p:spPr>
         <p:txBody>
@@ -5178,8 +5178,8 @@
         </p:nvSpPr>
         <p:spPr>
           <a:xfrm>
-            <a:off x="6300216" y="1664208"/>
-            <a:ext cx="2651760" cy="4297680"/>
+            <a:off x="8403336" y="1664208"/>
+            <a:ext cx="3538728" cy="4297680"/>
           </a:xfrm>
         </p:spPr>
         <p:txBody>
@@ -5311,8 +5311,8 @@
         </p:nvSpPr>
         <p:spPr>
           <a:xfrm>
-            <a:off x="274320" y="6309360"/>
-            <a:ext cx="8595360" cy="365760"/>
+            <a:off x="365760" y="6309360"/>
+            <a:ext cx="11430000" cy="365760"/>
           </a:xfrm>
         </p:spPr>
         <p:txBody>
@@ -5386,7 +5386,7 @@
         <p:spPr>
           <a:xfrm>
             <a:off x="0" y="0"/>
-            <a:ext cx="9144000" cy="6858000"/>
+            <a:ext cx="12192000" cy="6858000"/>
           </a:xfrm>
           <a:solidFill>
             <a:srgbClr val="1C2B4A">
@@ -5426,7 +5426,7 @@
         <p:spPr>
           <a:xfrm>
             <a:off x="0" y="0"/>
-            <a:ext cx="9144000" cy="822960"/>
+            <a:ext cx="12192000" cy="822960"/>
           </a:xfrm>
           <a:solidFill>
             <a:srgbClr val="1D9E75">
@@ -5465,8 +5465,8 @@
         </p:nvSpPr>
         <p:spPr>
           <a:xfrm>
-            <a:off x="365760" y="91440"/>
-            <a:ext cx="8229600" cy="640080"/>
+            <a:off x="457200" y="91440"/>
+            <a:ext cx="11277600" cy="640080"/>
           </a:xfrm>
         </p:spPr>
         <p:txBody>
@@ -5514,8 +5514,8 @@
         </p:nvSpPr>
         <p:spPr>
           <a:xfrm>
-            <a:off x="137160" y="987552"/>
-            <a:ext cx="2377440" cy="320040"/>
+            <a:off x="182880" y="987552"/>
+            <a:ext cx="3172968" cy="320040"/>
           </a:xfrm>
         </p:spPr>
         <p:txBody>
@@ -5563,8 +5563,8 @@
         </p:nvSpPr>
         <p:spPr>
           <a:xfrm>
-            <a:off x="2743200" y="987552"/>
-            <a:ext cx="3931920" cy="320040"/>
+            <a:off x="3657600" y="987552"/>
+            <a:ext cx="5239512" cy="320040"/>
           </a:xfrm>
         </p:spPr>
         <p:txBody>
@@ -5612,8 +5612,8 @@
         </p:nvSpPr>
         <p:spPr>
           <a:xfrm>
-            <a:off x="6949440" y="987552"/>
-            <a:ext cx="1920240" cy="320040"/>
+            <a:off x="9262872" y="987552"/>
+            <a:ext cx="2560320" cy="320040"/>
           </a:xfrm>
         </p:spPr>
         <p:txBody>
@@ -5661,8 +5661,8 @@
         </p:nvSpPr>
         <p:spPr>
           <a:xfrm>
-            <a:off x="137160" y="1371600"/>
-            <a:ext cx="2377440" cy="2011680"/>
+            <a:off x="182880" y="1371600"/>
+            <a:ext cx="3172968" cy="2011680"/>
           </a:xfrm>
           <a:solidFill>
             <a:srgbClr val="2A3F6A">
@@ -5701,8 +5701,8 @@
         </p:nvSpPr>
         <p:spPr>
           <a:xfrm>
-            <a:off x="137160" y="1463040"/>
-            <a:ext cx="2377440" cy="594360"/>
+            <a:off x="182880" y="1463040"/>
+            <a:ext cx="3172968" cy="594360"/>
           </a:xfrm>
         </p:spPr>
         <p:txBody>
@@ -5751,8 +5751,8 @@
         </p:nvSpPr>
         <p:spPr>
           <a:xfrm>
-            <a:off x="182880" y="2103120"/>
-            <a:ext cx="2286000" cy="1188720"/>
+            <a:off x="246888" y="2103120"/>
+            <a:ext cx="3044952" cy="1188720"/>
           </a:xfrm>
         </p:spPr>
         <p:txBody>
@@ -5884,8 +5884,8 @@
         </p:nvSpPr>
         <p:spPr>
           <a:xfrm>
-            <a:off x="137160" y="3566160"/>
-            <a:ext cx="2377440" cy="2011680"/>
+            <a:off x="182880" y="3566160"/>
+            <a:ext cx="3172968" cy="2011680"/>
           </a:xfrm>
           <a:solidFill>
             <a:srgbClr val="2A3F6A">
@@ -5924,8 +5924,8 @@
         </p:nvSpPr>
         <p:spPr>
           <a:xfrm>
-            <a:off x="137160" y="3657600"/>
-            <a:ext cx="2377440" cy="594360"/>
+            <a:off x="182880" y="3657600"/>
+            <a:ext cx="3172968" cy="594360"/>
           </a:xfrm>
         </p:spPr>
         <p:txBody>
@@ -5974,8 +5974,8 @@
         </p:nvSpPr>
         <p:spPr>
           <a:xfrm>
-            <a:off x="182880" y="4251960"/>
-            <a:ext cx="2286000" cy="1234440"/>
+            <a:off x="246888" y="4251960"/>
+            <a:ext cx="3044952" cy="1234440"/>
           </a:xfrm>
         </p:spPr>
         <p:txBody>
@@ -6107,8 +6107,8 @@
         </p:nvSpPr>
         <p:spPr>
           <a:xfrm>
-            <a:off x="2542032" y="2148840"/>
-            <a:ext cx="274320" cy="411480"/>
+            <a:off x="3392424" y="2148840"/>
+            <a:ext cx="365760" cy="411480"/>
           </a:xfrm>
         </p:spPr>
         <p:txBody>
@@ -6156,8 +6156,8 @@
         </p:nvSpPr>
         <p:spPr>
           <a:xfrm>
-            <a:off x="2542032" y="3566160"/>
-            <a:ext cx="274320" cy="411480"/>
+            <a:off x="3392424" y="3566160"/>
+            <a:ext cx="365760" cy="411480"/>
           </a:xfrm>
         </p:spPr>
         <p:txBody>
@@ -6205,8 +6205,8 @@
         </p:nvSpPr>
         <p:spPr>
           <a:xfrm>
-            <a:off x="6675120" y="3017520"/>
-            <a:ext cx="274320" cy="457200"/>
+            <a:off x="8897112" y="3017520"/>
+            <a:ext cx="365760" cy="457200"/>
           </a:xfrm>
         </p:spPr>
         <p:txBody>
@@ -6254,8 +6254,8 @@
         </p:nvSpPr>
         <p:spPr>
           <a:xfrm>
-            <a:off x="2743200" y="1371600"/>
-            <a:ext cx="3931920" cy="1234440"/>
+            <a:off x="3657600" y="1371600"/>
+            <a:ext cx="5239512" cy="1234440"/>
           </a:xfrm>
           <a:solidFill>
             <a:srgbClr val="1D5C46">
@@ -6294,8 +6294,8 @@
         </p:nvSpPr>
         <p:spPr>
           <a:xfrm>
-            <a:off x="2880360" y="1444752"/>
-            <a:ext cx="3749040" cy="457200"/>
+            <a:off x="3840480" y="1444752"/>
+            <a:ext cx="4937760" cy="457200"/>
           </a:xfrm>
         </p:spPr>
         <p:txBody>
@@ -6343,8 +6343,8 @@
         </p:nvSpPr>
         <p:spPr>
           <a:xfrm>
-            <a:off x="2880360" y="1920240"/>
-            <a:ext cx="3749040" cy="594360"/>
+            <a:off x="3840480" y="1920240"/>
+            <a:ext cx="4937760" cy="594360"/>
           </a:xfrm>
         </p:spPr>
         <p:txBody>
@@ -6420,8 +6420,8 @@
         </p:nvSpPr>
         <p:spPr>
           <a:xfrm>
-            <a:off x="2743200" y="2788920"/>
-            <a:ext cx="3931920" cy="1234440"/>
+            <a:off x="3657600" y="2788920"/>
+            <a:ext cx="5239512" cy="1234440"/>
           </a:xfrm>
           <a:solidFill>
             <a:srgbClr val="1A4A7A">
@@ -6460,8 +6460,8 @@
         </p:nvSpPr>
         <p:spPr>
           <a:xfrm>
-            <a:off x="2880360" y="2862072"/>
-            <a:ext cx="3749040" cy="457200"/>
+            <a:off x="3840480" y="2862072"/>
+            <a:ext cx="4937760" cy="457200"/>
           </a:xfrm>
         </p:spPr>
         <p:txBody>
@@ -6509,8 +6509,8 @@
         </p:nvSpPr>
         <p:spPr>
           <a:xfrm>
-            <a:off x="2880360" y="3337560"/>
-            <a:ext cx="3749040" cy="594360"/>
+            <a:off x="3840480" y="3337560"/>
+            <a:ext cx="4937760" cy="594360"/>
           </a:xfrm>
         </p:spPr>
         <p:txBody>
@@ -6586,8 +6586,8 @@
         </p:nvSpPr>
         <p:spPr>
           <a:xfrm>
-            <a:off x="2743200" y="4206240"/>
-            <a:ext cx="3931920" cy="1234440"/>
+            <a:off x="3657600" y="4206240"/>
+            <a:ext cx="5239512" cy="1234440"/>
           </a:xfrm>
           <a:solidFill>
             <a:srgbClr val="6B4C1A">
@@ -6626,8 +6626,8 @@
         </p:nvSpPr>
         <p:spPr>
           <a:xfrm>
-            <a:off x="2880360" y="4279392"/>
-            <a:ext cx="3749040" cy="457200"/>
+            <a:off x="3840480" y="4279392"/>
+            <a:ext cx="4937760" cy="457200"/>
           </a:xfrm>
         </p:spPr>
         <p:txBody>
@@ -6675,8 +6675,8 @@
         </p:nvSpPr>
         <p:spPr>
           <a:xfrm>
-            <a:off x="2880360" y="4754880"/>
-            <a:ext cx="3749040" cy="594360"/>
+            <a:off x="3840480" y="4754880"/>
+            <a:ext cx="4937760" cy="594360"/>
           </a:xfrm>
         </p:spPr>
         <p:txBody>
@@ -6752,8 +6752,8 @@
         </p:nvSpPr>
         <p:spPr>
           <a:xfrm>
-            <a:off x="6949440" y="1371600"/>
-            <a:ext cx="2011680" cy="4663440"/>
+            <a:off x="9262872" y="1371600"/>
+            <a:ext cx="2679192" cy="4663440"/>
           </a:xfrm>
           <a:solidFill>
             <a:srgbClr val="1D5038">
@@ -6792,8 +6792,8 @@
         </p:nvSpPr>
         <p:spPr>
           <a:xfrm>
-            <a:off x="6949440" y="1463040"/>
-            <a:ext cx="2011680" cy="365760"/>
+            <a:off x="9262872" y="1463040"/>
+            <a:ext cx="2679192" cy="365760"/>
           </a:xfrm>
         </p:spPr>
         <p:txBody>
@@ -6841,8 +6841,8 @@
         </p:nvSpPr>
         <p:spPr>
           <a:xfrm>
-            <a:off x="6995160" y="1920240"/>
-            <a:ext cx="1920240" cy="3840480"/>
+            <a:off x="9326880" y="1920240"/>
+            <a:ext cx="2560320" cy="3840480"/>
           </a:xfrm>
         </p:spPr>
         <p:txBody>
@@ -7112,7 +7112,7 @@
         <p:spPr>
           <a:xfrm>
             <a:off x="0" y="0"/>
-            <a:ext cx="9144000" cy="6858000"/>
+            <a:ext cx="12192000" cy="6858000"/>
           </a:xfrm>
           <a:solidFill>
             <a:srgbClr val="1C2B4A">
@@ -7152,7 +7152,7 @@
         <p:spPr>
           <a:xfrm>
             <a:off x="0" y="0"/>
-            <a:ext cx="9144000" cy="822960"/>
+            <a:ext cx="12192000" cy="822960"/>
           </a:xfrm>
           <a:solidFill>
             <a:srgbClr val="1D9E75">
@@ -7191,8 +7191,8 @@
         </p:nvSpPr>
         <p:spPr>
           <a:xfrm>
-            <a:off x="365760" y="91440"/>
-            <a:ext cx="8229600" cy="640080"/>
+            <a:off x="457200" y="91440"/>
+            <a:ext cx="11277600" cy="640080"/>
           </a:xfrm>
         </p:spPr>
         <p:txBody>
@@ -7240,8 +7240,8 @@
         </p:nvSpPr>
         <p:spPr>
           <a:xfrm>
-            <a:off x="274320" y="1005840"/>
-            <a:ext cx="2103120" cy="1508760"/>
+            <a:off x="365760" y="1005840"/>
+            <a:ext cx="2807208" cy="1508760"/>
           </a:xfrm>
           <a:solidFill>
             <a:srgbClr val="1A2840">
@@ -7280,7 +7280,7 @@
         </p:nvSpPr>
         <p:spPr>
           <a:xfrm>
-            <a:off x="338328" y="1143000"/>
+            <a:off x="448056" y="1143000"/>
             <a:ext cx="64008" cy="1188720"/>
           </a:xfrm>
           <a:solidFill>
@@ -7320,8 +7320,8 @@
         </p:nvSpPr>
         <p:spPr>
           <a:xfrm>
-            <a:off x="502920" y="1143000"/>
-            <a:ext cx="1828800" cy="502920"/>
+            <a:off x="667512" y="1143000"/>
+            <a:ext cx="2441448" cy="502920"/>
           </a:xfrm>
         </p:spPr>
         <p:txBody>
@@ -7369,8 +7369,8 @@
         </p:nvSpPr>
         <p:spPr>
           <a:xfrm>
-            <a:off x="502920" y="1664208"/>
-            <a:ext cx="1828800" cy="347472"/>
+            <a:off x="667512" y="1664208"/>
+            <a:ext cx="2441448" cy="347472"/>
           </a:xfrm>
         </p:spPr>
         <p:txBody>
@@ -7418,8 +7418,8 @@
         </p:nvSpPr>
         <p:spPr>
           <a:xfrm>
-            <a:off x="502920" y="2011680"/>
-            <a:ext cx="1828800" cy="347472"/>
+            <a:off x="667512" y="2011680"/>
+            <a:ext cx="2441448" cy="347472"/>
           </a:xfrm>
         </p:spPr>
         <p:txBody>
@@ -7467,8 +7467,8 @@
         </p:nvSpPr>
         <p:spPr>
           <a:xfrm>
-            <a:off x="2514600" y="1005840"/>
-            <a:ext cx="2103120" cy="1508760"/>
+            <a:off x="3355848" y="1005840"/>
+            <a:ext cx="2807208" cy="1508760"/>
           </a:xfrm>
           <a:solidFill>
             <a:srgbClr val="1A2840">
@@ -7507,7 +7507,7 @@
         </p:nvSpPr>
         <p:spPr>
           <a:xfrm>
-            <a:off x="2578608" y="1143000"/>
+            <a:off x="3438144" y="1143000"/>
             <a:ext cx="64008" cy="1188720"/>
           </a:xfrm>
           <a:solidFill>
@@ -7547,8 +7547,8 @@
         </p:nvSpPr>
         <p:spPr>
           <a:xfrm>
-            <a:off x="2743200" y="1143000"/>
-            <a:ext cx="1828800" cy="502920"/>
+            <a:off x="3657600" y="1143000"/>
+            <a:ext cx="2441448" cy="502920"/>
           </a:xfrm>
         </p:spPr>
         <p:txBody>
@@ -7596,8 +7596,8 @@
         </p:nvSpPr>
         <p:spPr>
           <a:xfrm>
-            <a:off x="2743200" y="1664208"/>
-            <a:ext cx="1828800" cy="347472"/>
+            <a:off x="3657600" y="1664208"/>
+            <a:ext cx="2441448" cy="347472"/>
           </a:xfrm>
         </p:spPr>
         <p:txBody>
@@ -7645,8 +7645,8 @@
         </p:nvSpPr>
         <p:spPr>
           <a:xfrm>
-            <a:off x="2743200" y="2011680"/>
-            <a:ext cx="1828800" cy="347472"/>
+            <a:off x="3657600" y="2011680"/>
+            <a:ext cx="2441448" cy="347472"/>
           </a:xfrm>
         </p:spPr>
         <p:txBody>
@@ -7694,8 +7694,8 @@
         </p:nvSpPr>
         <p:spPr>
           <a:xfrm>
-            <a:off x="274320" y="2743200"/>
-            <a:ext cx="2103120" cy="1508760"/>
+            <a:off x="365760" y="2743200"/>
+            <a:ext cx="2807208" cy="1508760"/>
           </a:xfrm>
           <a:solidFill>
             <a:srgbClr val="1A2840">
@@ -7734,7 +7734,7 @@
         </p:nvSpPr>
         <p:spPr>
           <a:xfrm>
-            <a:off x="338328" y="2880360"/>
+            <a:off x="448056" y="2880360"/>
             <a:ext cx="64008" cy="1188720"/>
           </a:xfrm>
           <a:solidFill>
@@ -7774,8 +7774,8 @@
         </p:nvSpPr>
         <p:spPr>
           <a:xfrm>
-            <a:off x="502920" y="2880360"/>
-            <a:ext cx="1828800" cy="502920"/>
+            <a:off x="667512" y="2880360"/>
+            <a:ext cx="2441448" cy="502920"/>
           </a:xfrm>
         </p:spPr>
         <p:txBody>
@@ -7823,8 +7823,8 @@
         </p:nvSpPr>
         <p:spPr>
           <a:xfrm>
-            <a:off x="502920" y="3401568"/>
-            <a:ext cx="1828800" cy="347472"/>
+            <a:off x="667512" y="3401568"/>
+            <a:ext cx="2441448" cy="347472"/>
           </a:xfrm>
         </p:spPr>
         <p:txBody>
@@ -7872,8 +7872,8 @@
         </p:nvSpPr>
         <p:spPr>
           <a:xfrm>
-            <a:off x="502920" y="3749040"/>
-            <a:ext cx="1828800" cy="347472"/>
+            <a:off x="667512" y="3749040"/>
+            <a:ext cx="2441448" cy="347472"/>
           </a:xfrm>
         </p:spPr>
         <p:txBody>
@@ -7921,8 +7921,8 @@
         </p:nvSpPr>
         <p:spPr>
           <a:xfrm>
-            <a:off x="2514600" y="2743200"/>
-            <a:ext cx="2103120" cy="1508760"/>
+            <a:off x="3355848" y="2743200"/>
+            <a:ext cx="2807208" cy="1508760"/>
           </a:xfrm>
           <a:solidFill>
             <a:srgbClr val="1A2840">
@@ -7961,7 +7961,7 @@
         </p:nvSpPr>
         <p:spPr>
           <a:xfrm>
-            <a:off x="2578608" y="2880360"/>
+            <a:off x="3438144" y="2880360"/>
             <a:ext cx="64008" cy="1188720"/>
           </a:xfrm>
           <a:solidFill>
@@ -8001,8 +8001,8 @@
         </p:nvSpPr>
         <p:spPr>
           <a:xfrm>
-            <a:off x="2743200" y="2880360"/>
-            <a:ext cx="1828800" cy="502920"/>
+            <a:off x="3657600" y="2880360"/>
+            <a:ext cx="2441448" cy="502920"/>
           </a:xfrm>
         </p:spPr>
         <p:txBody>
@@ -8050,8 +8050,8 @@
         </p:nvSpPr>
         <p:spPr>
           <a:xfrm>
-            <a:off x="2743200" y="3401568"/>
-            <a:ext cx="1828800" cy="347472"/>
+            <a:off x="3657600" y="3401568"/>
+            <a:ext cx="2441448" cy="347472"/>
           </a:xfrm>
         </p:spPr>
         <p:txBody>
@@ -8099,8 +8099,8 @@
         </p:nvSpPr>
         <p:spPr>
           <a:xfrm>
-            <a:off x="2743200" y="3749040"/>
-            <a:ext cx="1828800" cy="347472"/>
+            <a:off x="3657600" y="3749040"/>
+            <a:ext cx="2441448" cy="347472"/>
           </a:xfrm>
         </p:spPr>
         <p:txBody>
@@ -8148,8 +8148,8 @@
         </p:nvSpPr>
         <p:spPr>
           <a:xfrm>
-            <a:off x="4800600" y="1005840"/>
-            <a:ext cx="4160520" cy="5394960"/>
+            <a:off x="6400800" y="1005840"/>
+            <a:ext cx="5550408" cy="5394960"/>
           </a:xfrm>
           <a:solidFill>
             <a:srgbClr val="1A2840">
@@ -8188,8 +8188,8 @@
         </p:nvSpPr>
         <p:spPr>
           <a:xfrm>
-            <a:off x="4983480" y="1097280"/>
-            <a:ext cx="3840480" cy="411480"/>
+            <a:off x="6647688" y="1097280"/>
+            <a:ext cx="5120640" cy="411480"/>
           </a:xfrm>
         </p:spPr>
         <p:txBody>
@@ -8237,8 +8237,8 @@
         </p:nvSpPr>
         <p:spPr>
           <a:xfrm>
-            <a:off x="4983480" y="1508760"/>
-            <a:ext cx="3840480" cy="320040"/>
+            <a:off x="6647688" y="1508760"/>
+            <a:ext cx="5120640" cy="320040"/>
           </a:xfrm>
         </p:spPr>
         <p:txBody>
@@ -8286,7 +8286,7 @@
         </p:nvSpPr>
         <p:spPr>
           <a:xfrm>
-            <a:off x="5001768" y="1920240"/>
+            <a:off x="6675120" y="1920240"/>
             <a:ext cx="64008" cy="457200"/>
           </a:xfrm>
           <a:solidFill>
@@ -8326,8 +8326,8 @@
         </p:nvSpPr>
         <p:spPr>
           <a:xfrm>
-            <a:off x="5166360" y="1920240"/>
-            <a:ext cx="2377440" cy="274320"/>
+            <a:off x="6885432" y="1920240"/>
+            <a:ext cx="3172968" cy="274320"/>
           </a:xfrm>
         </p:spPr>
         <p:txBody>
@@ -8375,8 +8375,8 @@
         </p:nvSpPr>
         <p:spPr>
           <a:xfrm>
-            <a:off x="5166360" y="2194560"/>
-            <a:ext cx="2377440" cy="256032"/>
+            <a:off x="6885432" y="2194560"/>
+            <a:ext cx="3172968" cy="256032"/>
           </a:xfrm>
         </p:spPr>
         <p:txBody>
@@ -8424,7 +8424,7 @@
         </p:nvSpPr>
         <p:spPr>
           <a:xfrm>
-            <a:off x="5001768" y="2624328"/>
+            <a:off x="6675120" y="2624328"/>
             <a:ext cx="64008" cy="457200"/>
           </a:xfrm>
           <a:solidFill>
@@ -8464,8 +8464,8 @@
         </p:nvSpPr>
         <p:spPr>
           <a:xfrm>
-            <a:off x="5166360" y="2624328"/>
-            <a:ext cx="2377440" cy="274320"/>
+            <a:off x="6885432" y="2624328"/>
+            <a:ext cx="3172968" cy="274320"/>
           </a:xfrm>
         </p:spPr>
         <p:txBody>
@@ -8513,8 +8513,8 @@
         </p:nvSpPr>
         <p:spPr>
           <a:xfrm>
-            <a:off x="5166360" y="2898648"/>
-            <a:ext cx="2377440" cy="256032"/>
+            <a:off x="6885432" y="2898648"/>
+            <a:ext cx="3172968" cy="256032"/>
           </a:xfrm>
         </p:spPr>
         <p:txBody>
@@ -8562,7 +8562,7 @@
         </p:nvSpPr>
         <p:spPr>
           <a:xfrm>
-            <a:off x="5001768" y="3328416"/>
+            <a:off x="6675120" y="3328416"/>
             <a:ext cx="64008" cy="457200"/>
           </a:xfrm>
           <a:solidFill>
@@ -8602,8 +8602,8 @@
         </p:nvSpPr>
         <p:spPr>
           <a:xfrm>
-            <a:off x="5166360" y="3328416"/>
-            <a:ext cx="2377440" cy="274320"/>
+            <a:off x="6885432" y="3328416"/>
+            <a:ext cx="3172968" cy="274320"/>
           </a:xfrm>
         </p:spPr>
         <p:txBody>
@@ -8651,8 +8651,8 @@
         </p:nvSpPr>
         <p:spPr>
           <a:xfrm>
-            <a:off x="5166360" y="3602736"/>
-            <a:ext cx="2377440" cy="256032"/>
+            <a:off x="6885432" y="3602736"/>
+            <a:ext cx="3172968" cy="256032"/>
           </a:xfrm>
         </p:spPr>
         <p:txBody>
@@ -8700,7 +8700,7 @@
         </p:nvSpPr>
         <p:spPr>
           <a:xfrm>
-            <a:off x="5001768" y="4032504"/>
+            <a:off x="6675120" y="4032504"/>
             <a:ext cx="64008" cy="457200"/>
           </a:xfrm>
           <a:solidFill>
@@ -8740,8 +8740,8 @@
         </p:nvSpPr>
         <p:spPr>
           <a:xfrm>
-            <a:off x="5166360" y="4032504"/>
-            <a:ext cx="2377440" cy="274320"/>
+            <a:off x="6885432" y="4032504"/>
+            <a:ext cx="3172968" cy="274320"/>
           </a:xfrm>
         </p:spPr>
         <p:txBody>
@@ -8789,8 +8789,8 @@
         </p:nvSpPr>
         <p:spPr>
           <a:xfrm>
-            <a:off x="5166360" y="4306824"/>
-            <a:ext cx="2377440" cy="256032"/>
+            <a:off x="6885432" y="4306824"/>
+            <a:ext cx="3172968" cy="256032"/>
           </a:xfrm>
         </p:spPr>
         <p:txBody>
@@ -8838,7 +8838,7 @@
         </p:nvSpPr>
         <p:spPr>
           <a:xfrm>
-            <a:off x="5001768" y="4736592"/>
+            <a:off x="6675120" y="4736592"/>
             <a:ext cx="64008" cy="457200"/>
           </a:xfrm>
           <a:solidFill>
@@ -8878,8 +8878,8 @@
         </p:nvSpPr>
         <p:spPr>
           <a:xfrm>
-            <a:off x="5166360" y="4736592"/>
-            <a:ext cx="2377440" cy="274320"/>
+            <a:off x="6885432" y="4736592"/>
+            <a:ext cx="3172968" cy="274320"/>
           </a:xfrm>
         </p:spPr>
         <p:txBody>
@@ -8927,8 +8927,8 @@
         </p:nvSpPr>
         <p:spPr>
           <a:xfrm>
-            <a:off x="5166360" y="5010912"/>
-            <a:ext cx="2377440" cy="256032"/>
+            <a:off x="6885432" y="5010912"/>
+            <a:ext cx="3172968" cy="256032"/>
           </a:xfrm>
         </p:spPr>
         <p:txBody>
@@ -8976,7 +8976,7 @@
         </p:nvSpPr>
         <p:spPr>
           <a:xfrm>
-            <a:off x="5001768" y="5440680"/>
+            <a:off x="6675120" y="5440680"/>
             <a:ext cx="64008" cy="457200"/>
           </a:xfrm>
           <a:solidFill>
@@ -9016,8 +9016,8 @@
         </p:nvSpPr>
         <p:spPr>
           <a:xfrm>
-            <a:off x="5166360" y="5440680"/>
-            <a:ext cx="2377440" cy="274320"/>
+            <a:off x="6885432" y="5440680"/>
+            <a:ext cx="3172968" cy="274320"/>
           </a:xfrm>
         </p:spPr>
         <p:txBody>
@@ -9065,8 +9065,8 @@
         </p:nvSpPr>
         <p:spPr>
           <a:xfrm>
-            <a:off x="5166360" y="5715000"/>
-            <a:ext cx="2377440" cy="256032"/>
+            <a:off x="6885432" y="5715000"/>
+            <a:ext cx="3172968" cy="256032"/>
           </a:xfrm>
         </p:spPr>
         <p:txBody>
@@ -9114,8 +9114,8 @@
         </p:nvSpPr>
         <p:spPr>
           <a:xfrm>
-            <a:off x="4983480" y="6126480"/>
-            <a:ext cx="3749040" cy="274320"/>
+            <a:off x="6647688" y="6126480"/>
+            <a:ext cx="5120640" cy="274320"/>
           </a:xfrm>
         </p:spPr>
         <p:txBody>
@@ -9189,7 +9189,7 @@
         <p:spPr>
           <a:xfrm>
             <a:off x="0" y="0"/>
-            <a:ext cx="9144000" cy="6858000"/>
+            <a:ext cx="12192000" cy="6858000"/>
           </a:xfrm>
           <a:solidFill>
             <a:srgbClr val="1C2B4A">
@@ -9229,7 +9229,7 @@
         <p:spPr>
           <a:xfrm>
             <a:off x="0" y="0"/>
-            <a:ext cx="9144000" cy="822960"/>
+            <a:ext cx="12192000" cy="822960"/>
           </a:xfrm>
           <a:solidFill>
             <a:srgbClr val="F39C12">
@@ -9268,8 +9268,8 @@
         </p:nvSpPr>
         <p:spPr>
           <a:xfrm>
-            <a:off x="365760" y="91440"/>
-            <a:ext cx="8229600" cy="640080"/>
+            <a:off x="457200" y="91440"/>
+            <a:ext cx="11277600" cy="640080"/>
           </a:xfrm>
         </p:spPr>
         <p:txBody>
@@ -9317,8 +9317,8 @@
         </p:nvSpPr>
         <p:spPr>
           <a:xfrm>
-            <a:off x="182880" y="1005840"/>
-            <a:ext cx="4160520" cy="5303520"/>
+            <a:off x="246888" y="1005840"/>
+            <a:ext cx="5669280" cy="5303520"/>
           </a:xfrm>
           <a:solidFill>
             <a:srgbClr val="1A2840">
@@ -9357,8 +9357,8 @@
         </p:nvSpPr>
         <p:spPr>
           <a:xfrm>
-            <a:off x="365760" y="1097280"/>
-            <a:ext cx="3840480" cy="457200"/>
+            <a:off x="484632" y="1097280"/>
+            <a:ext cx="5239512" cy="457200"/>
           </a:xfrm>
         </p:spPr>
         <p:txBody>
@@ -9406,8 +9406,8 @@
         </p:nvSpPr>
         <p:spPr>
           <a:xfrm>
-            <a:off x="365760" y="1645920"/>
-            <a:ext cx="3840480" cy="4389120"/>
+            <a:off x="484632" y="1645920"/>
+            <a:ext cx="5239512" cy="4389120"/>
           </a:xfrm>
         </p:spPr>
         <p:txBody>
@@ -9595,8 +9595,8 @@
         </p:nvSpPr>
         <p:spPr>
           <a:xfrm>
-            <a:off x="4617720" y="1005840"/>
-            <a:ext cx="4343400" cy="5303520"/>
+            <a:off x="6153912" y="1005840"/>
+            <a:ext cx="5788152" cy="5303520"/>
           </a:xfrm>
           <a:solidFill>
             <a:srgbClr val="1A2840">
@@ -9635,8 +9635,8 @@
         </p:nvSpPr>
         <p:spPr>
           <a:xfrm>
-            <a:off x="4800600" y="1097280"/>
-            <a:ext cx="4023360" cy="457200"/>
+            <a:off x="6400800" y="1097280"/>
+            <a:ext cx="5367528" cy="457200"/>
           </a:xfrm>
         </p:spPr>
         <p:txBody>
@@ -9684,8 +9684,8 @@
         </p:nvSpPr>
         <p:spPr>
           <a:xfrm>
-            <a:off x="4800600" y="1645920"/>
-            <a:ext cx="4023360" cy="4389120"/>
+            <a:off x="6400800" y="1645920"/>
+            <a:ext cx="5367528" cy="4389120"/>
           </a:xfrm>
         </p:spPr>
         <p:txBody>
@@ -9899,7 +9899,7 @@
         <p:spPr>
           <a:xfrm>
             <a:off x="0" y="0"/>
-            <a:ext cx="9144000" cy="6858000"/>
+            <a:ext cx="12192000" cy="6858000"/>
           </a:xfrm>
           <a:solidFill>
             <a:srgbClr val="1C2B4A">
@@ -9939,7 +9939,7 @@
         <p:spPr>
           <a:xfrm>
             <a:off x="0" y="0"/>
-            <a:ext cx="9144000" cy="822960"/>
+            <a:ext cx="12192000" cy="822960"/>
           </a:xfrm>
           <a:solidFill>
             <a:srgbClr val="378ADD">
@@ -9978,8 +9978,8 @@
         </p:nvSpPr>
         <p:spPr>
           <a:xfrm>
-            <a:off x="365760" y="91440"/>
-            <a:ext cx="8229600" cy="640080"/>
+            <a:off x="457200" y="91440"/>
+            <a:ext cx="11277600" cy="640080"/>
           </a:xfrm>
         </p:spPr>
         <p:txBody>
@@ -10027,8 +10027,8 @@
         </p:nvSpPr>
         <p:spPr>
           <a:xfrm>
-            <a:off x="457200" y="914400"/>
-            <a:ext cx="8229600" cy="411480"/>
+            <a:off x="612648" y="914400"/>
+            <a:ext cx="10972800" cy="411480"/>
           </a:xfrm>
         </p:spPr>
         <p:txBody>
@@ -10076,8 +10076,8 @@
         </p:nvSpPr>
         <p:spPr>
           <a:xfrm>
-            <a:off x="457200" y="1325880"/>
-            <a:ext cx="8229600" cy="365760"/>
+            <a:off x="612648" y="1325880"/>
+            <a:ext cx="10972800" cy="365760"/>
           </a:xfrm>
         </p:spPr>
         <p:txBody>
@@ -10125,8 +10125,8 @@
         </p:nvSpPr>
         <p:spPr>
           <a:xfrm>
-            <a:off x="137160" y="1874520"/>
-            <a:ext cx="2148840" cy="2057400"/>
+            <a:off x="182880" y="1874520"/>
+            <a:ext cx="2862072" cy="2057400"/>
           </a:xfrm>
           <a:solidFill>
             <a:srgbClr val="1A2840">
@@ -10165,8 +10165,8 @@
         </p:nvSpPr>
         <p:spPr>
           <a:xfrm>
-            <a:off x="228600" y="1938528"/>
-            <a:ext cx="1965960" cy="54864"/>
+            <a:off x="301752" y="1938528"/>
+            <a:ext cx="2624328" cy="54864"/>
           </a:xfrm>
           <a:solidFill>
             <a:srgbClr val="F39C12">
@@ -10205,8 +10205,8 @@
         </p:nvSpPr>
         <p:spPr>
           <a:xfrm>
-            <a:off x="246888" y="2039112"/>
-            <a:ext cx="1965960" cy="457200"/>
+            <a:off x="329184" y="2039112"/>
+            <a:ext cx="2624328" cy="457200"/>
           </a:xfrm>
         </p:spPr>
         <p:txBody>
@@ -10254,8 +10254,8 @@
         </p:nvSpPr>
         <p:spPr>
           <a:xfrm>
-            <a:off x="246888" y="2532888"/>
-            <a:ext cx="1965960" cy="594360"/>
+            <a:off x="329184" y="2532888"/>
+            <a:ext cx="2624328" cy="594360"/>
           </a:xfrm>
         </p:spPr>
         <p:txBody>
@@ -10303,8 +10303,8 @@
         </p:nvSpPr>
         <p:spPr>
           <a:xfrm>
-            <a:off x="246888" y="3200400"/>
-            <a:ext cx="1965960" cy="502920"/>
+            <a:off x="329184" y="3200400"/>
+            <a:ext cx="2624328" cy="502920"/>
           </a:xfrm>
         </p:spPr>
         <p:txBody>
@@ -10352,8 +10352,8 @@
         </p:nvSpPr>
         <p:spPr>
           <a:xfrm>
-            <a:off x="2395728" y="1874520"/>
-            <a:ext cx="2148840" cy="2057400"/>
+            <a:off x="3200400" y="1874520"/>
+            <a:ext cx="2862072" cy="2057400"/>
           </a:xfrm>
           <a:solidFill>
             <a:srgbClr val="1A2840">
@@ -10392,8 +10392,8 @@
         </p:nvSpPr>
         <p:spPr>
           <a:xfrm>
-            <a:off x="2487168" y="1938528"/>
-            <a:ext cx="1965960" cy="54864"/>
+            <a:off x="3319272" y="1938528"/>
+            <a:ext cx="2624328" cy="54864"/>
           </a:xfrm>
           <a:solidFill>
             <a:srgbClr val="F39C12">
@@ -10432,8 +10432,8 @@
         </p:nvSpPr>
         <p:spPr>
           <a:xfrm>
-            <a:off x="2505456" y="2039112"/>
-            <a:ext cx="1965960" cy="457200"/>
+            <a:off x="3346704" y="2039112"/>
+            <a:ext cx="2624328" cy="457200"/>
           </a:xfrm>
         </p:spPr>
         <p:txBody>
@@ -10481,8 +10481,8 @@
         </p:nvSpPr>
         <p:spPr>
           <a:xfrm>
-            <a:off x="2505456" y="2532888"/>
-            <a:ext cx="1965960" cy="594360"/>
+            <a:off x="3346704" y="2532888"/>
+            <a:ext cx="2624328" cy="594360"/>
           </a:xfrm>
         </p:spPr>
         <p:txBody>
@@ -10530,8 +10530,8 @@
         </p:nvSpPr>
         <p:spPr>
           <a:xfrm>
-            <a:off x="2505456" y="3200400"/>
-            <a:ext cx="1965960" cy="502920"/>
+            <a:off x="3346704" y="3200400"/>
+            <a:ext cx="2624328" cy="502920"/>
           </a:xfrm>
         </p:spPr>
         <p:txBody>
@@ -10579,8 +10579,8 @@
         </p:nvSpPr>
         <p:spPr>
           <a:xfrm>
-            <a:off x="4654296" y="1874520"/>
-            <a:ext cx="2148840" cy="2057400"/>
+            <a:off x="6217920" y="1874520"/>
+            <a:ext cx="2862072" cy="2057400"/>
           </a:xfrm>
           <a:solidFill>
             <a:srgbClr val="1A2840">
@@ -10619,8 +10619,8 @@
         </p:nvSpPr>
         <p:spPr>
           <a:xfrm>
-            <a:off x="4745736" y="1938528"/>
-            <a:ext cx="1965960" cy="54864"/>
+            <a:off x="6336792" y="1938528"/>
+            <a:ext cx="2624328" cy="54864"/>
           </a:xfrm>
           <a:solidFill>
             <a:srgbClr val="F39C12">
@@ -10659,8 +10659,8 @@
         </p:nvSpPr>
         <p:spPr>
           <a:xfrm>
-            <a:off x="4764024" y="2039112"/>
-            <a:ext cx="1965960" cy="457200"/>
+            <a:off x="6364224" y="2039112"/>
+            <a:ext cx="2624328" cy="457200"/>
           </a:xfrm>
         </p:spPr>
         <p:txBody>
@@ -10708,8 +10708,8 @@
         </p:nvSpPr>
         <p:spPr>
           <a:xfrm>
-            <a:off x="4764024" y="2532888"/>
-            <a:ext cx="1965960" cy="594360"/>
+            <a:off x="6364224" y="2532888"/>
+            <a:ext cx="2624328" cy="594360"/>
           </a:xfrm>
         </p:spPr>
         <p:txBody>
@@ -10757,8 +10757,8 @@
         </p:nvSpPr>
         <p:spPr>
           <a:xfrm>
-            <a:off x="4764024" y="3200400"/>
-            <a:ext cx="1965960" cy="502920"/>
+            <a:off x="6364224" y="3200400"/>
+            <a:ext cx="2624328" cy="502920"/>
           </a:xfrm>
         </p:spPr>
         <p:txBody>
@@ -10806,8 +10806,8 @@
         </p:nvSpPr>
         <p:spPr>
           <a:xfrm>
-            <a:off x="6912864" y="1874520"/>
-            <a:ext cx="2148840" cy="2057400"/>
+            <a:off x="9235440" y="1874520"/>
+            <a:ext cx="2862072" cy="2057400"/>
           </a:xfrm>
           <a:solidFill>
             <a:srgbClr val="1A2840">
@@ -10846,8 +10846,8 @@
         </p:nvSpPr>
         <p:spPr>
           <a:xfrm>
-            <a:off x="7004304" y="1938528"/>
-            <a:ext cx="1965960" cy="54864"/>
+            <a:off x="9354312" y="1938528"/>
+            <a:ext cx="2624328" cy="54864"/>
           </a:xfrm>
           <a:solidFill>
             <a:srgbClr val="F39C12">
@@ -10886,8 +10886,8 @@
         </p:nvSpPr>
         <p:spPr>
           <a:xfrm>
-            <a:off x="7022592" y="2039112"/>
-            <a:ext cx="1965960" cy="457200"/>
+            <a:off x="9381744" y="2039112"/>
+            <a:ext cx="2624328" cy="457200"/>
           </a:xfrm>
         </p:spPr>
         <p:txBody>
@@ -10935,8 +10935,8 @@
         </p:nvSpPr>
         <p:spPr>
           <a:xfrm>
-            <a:off x="7022592" y="2532888"/>
-            <a:ext cx="1965960" cy="594360"/>
+            <a:off x="9381744" y="2532888"/>
+            <a:ext cx="2624328" cy="594360"/>
           </a:xfrm>
         </p:spPr>
         <p:txBody>
@@ -10984,8 +10984,8 @@
         </p:nvSpPr>
         <p:spPr>
           <a:xfrm>
-            <a:off x="7022592" y="3200400"/>
-            <a:ext cx="1965960" cy="502920"/>
+            <a:off x="9381744" y="3200400"/>
+            <a:ext cx="2624328" cy="502920"/>
           </a:xfrm>
         </p:spPr>
         <p:txBody>
@@ -11033,8 +11033,8 @@
         </p:nvSpPr>
         <p:spPr>
           <a:xfrm>
-            <a:off x="137160" y="4160520"/>
-            <a:ext cx="2148840" cy="2057400"/>
+            <a:off x="182880" y="4160520"/>
+            <a:ext cx="2862072" cy="2057400"/>
           </a:xfrm>
           <a:solidFill>
             <a:srgbClr val="1A2840">
@@ -11073,8 +11073,8 @@
         </p:nvSpPr>
         <p:spPr>
           <a:xfrm>
-            <a:off x="228600" y="4224528"/>
-            <a:ext cx="1965960" cy="54864"/>
+            <a:off x="301752" y="4224528"/>
+            <a:ext cx="2624328" cy="54864"/>
           </a:xfrm>
           <a:solidFill>
             <a:srgbClr val="378ADD">
@@ -11113,8 +11113,8 @@
         </p:nvSpPr>
         <p:spPr>
           <a:xfrm>
-            <a:off x="246888" y="4325112"/>
-            <a:ext cx="1965960" cy="457200"/>
+            <a:off x="329184" y="4325112"/>
+            <a:ext cx="2624328" cy="457200"/>
           </a:xfrm>
         </p:spPr>
         <p:txBody>
@@ -11162,8 +11162,8 @@
         </p:nvSpPr>
         <p:spPr>
           <a:xfrm>
-            <a:off x="246888" y="4818888"/>
-            <a:ext cx="1965960" cy="594360"/>
+            <a:off x="329184" y="4818888"/>
+            <a:ext cx="2624328" cy="594360"/>
           </a:xfrm>
         </p:spPr>
         <p:txBody>
@@ -11211,8 +11211,8 @@
         </p:nvSpPr>
         <p:spPr>
           <a:xfrm>
-            <a:off x="246888" y="5486400"/>
-            <a:ext cx="1965960" cy="502920"/>
+            <a:off x="329184" y="5486400"/>
+            <a:ext cx="2624328" cy="502920"/>
           </a:xfrm>
         </p:spPr>
         <p:txBody>
@@ -11260,8 +11260,8 @@
         </p:nvSpPr>
         <p:spPr>
           <a:xfrm>
-            <a:off x="2395728" y="4160520"/>
-            <a:ext cx="2148840" cy="2057400"/>
+            <a:off x="3200400" y="4160520"/>
+            <a:ext cx="2862072" cy="2057400"/>
           </a:xfrm>
           <a:solidFill>
             <a:srgbClr val="1A2840">
@@ -11300,8 +11300,8 @@
         </p:nvSpPr>
         <p:spPr>
           <a:xfrm>
-            <a:off x="2487168" y="4224528"/>
-            <a:ext cx="1965960" cy="54864"/>
+            <a:off x="3319272" y="4224528"/>
+            <a:ext cx="2624328" cy="54864"/>
           </a:xfrm>
           <a:solidFill>
             <a:srgbClr val="1D9E75">
@@ -11340,8 +11340,8 @@
         </p:nvSpPr>
         <p:spPr>
           <a:xfrm>
-            <a:off x="2505456" y="4325112"/>
-            <a:ext cx="1965960" cy="457200"/>
+            <a:off x="3346704" y="4325112"/>
+            <a:ext cx="2624328" cy="457200"/>
           </a:xfrm>
         </p:spPr>
         <p:txBody>
@@ -11389,8 +11389,8 @@
         </p:nvSpPr>
         <p:spPr>
           <a:xfrm>
-            <a:off x="2505456" y="4818888"/>
-            <a:ext cx="1965960" cy="594360"/>
+            <a:off x="3346704" y="4818888"/>
+            <a:ext cx="2624328" cy="594360"/>
           </a:xfrm>
         </p:spPr>
         <p:txBody>
@@ -11438,8 +11438,8 @@
         </p:nvSpPr>
         <p:spPr>
           <a:xfrm>
-            <a:off x="2505456" y="5486400"/>
-            <a:ext cx="1965960" cy="502920"/>
+            <a:off x="3346704" y="5486400"/>
+            <a:ext cx="2624328" cy="502920"/>
           </a:xfrm>
         </p:spPr>
         <p:txBody>
@@ -11487,8 +11487,8 @@
         </p:nvSpPr>
         <p:spPr>
           <a:xfrm>
-            <a:off x="4654296" y="4160520"/>
-            <a:ext cx="2148840" cy="2057400"/>
+            <a:off x="6217920" y="4160520"/>
+            <a:ext cx="2862072" cy="2057400"/>
           </a:xfrm>
           <a:solidFill>
             <a:srgbClr val="1A2840">
@@ -11527,8 +11527,8 @@
         </p:nvSpPr>
         <p:spPr>
           <a:xfrm>
-            <a:off x="4745736" y="4224528"/>
-            <a:ext cx="1965960" cy="54864"/>
+            <a:off x="6336792" y="4224528"/>
+            <a:ext cx="2624328" cy="54864"/>
           </a:xfrm>
           <a:solidFill>
             <a:srgbClr val="3DC494">
@@ -11567,8 +11567,8 @@
         </p:nvSpPr>
         <p:spPr>
           <a:xfrm>
-            <a:off x="4764024" y="4325112"/>
-            <a:ext cx="1965960" cy="457200"/>
+            <a:off x="6364224" y="4325112"/>
+            <a:ext cx="2624328" cy="457200"/>
           </a:xfrm>
         </p:spPr>
         <p:txBody>
@@ -11616,8 +11616,8 @@
         </p:nvSpPr>
         <p:spPr>
           <a:xfrm>
-            <a:off x="4764024" y="4818888"/>
-            <a:ext cx="1965960" cy="594360"/>
+            <a:off x="6364224" y="4818888"/>
+            <a:ext cx="2624328" cy="594360"/>
           </a:xfrm>
         </p:spPr>
         <p:txBody>
@@ -11665,8 +11665,8 @@
         </p:nvSpPr>
         <p:spPr>
           <a:xfrm>
-            <a:off x="4764024" y="5486400"/>
-            <a:ext cx="1965960" cy="502920"/>
+            <a:off x="6364224" y="5486400"/>
+            <a:ext cx="2624328" cy="502920"/>
           </a:xfrm>
         </p:spPr>
         <p:txBody>
@@ -11714,8 +11714,8 @@
         </p:nvSpPr>
         <p:spPr>
           <a:xfrm>
-            <a:off x="6912864" y="4160520"/>
-            <a:ext cx="2148840" cy="2057400"/>
+            <a:off x="9235440" y="4160520"/>
+            <a:ext cx="2862072" cy="2057400"/>
           </a:xfrm>
           <a:solidFill>
             <a:srgbClr val="1A2840">
@@ -11754,8 +11754,8 @@
         </p:nvSpPr>
         <p:spPr>
           <a:xfrm>
-            <a:off x="7004304" y="4224528"/>
-            <a:ext cx="1965960" cy="54864"/>
+            <a:off x="9354312" y="4224528"/>
+            <a:ext cx="2624328" cy="54864"/>
           </a:xfrm>
           <a:solidFill>
             <a:srgbClr val="3DC494">
@@ -11794,8 +11794,8 @@
         </p:nvSpPr>
         <p:spPr>
           <a:xfrm>
-            <a:off x="7022592" y="4325112"/>
-            <a:ext cx="1965960" cy="457200"/>
+            <a:off x="9381744" y="4325112"/>
+            <a:ext cx="2624328" cy="457200"/>
           </a:xfrm>
         </p:spPr>
         <p:txBody>
@@ -11843,8 +11843,8 @@
         </p:nvSpPr>
         <p:spPr>
           <a:xfrm>
-            <a:off x="7022592" y="4818888"/>
-            <a:ext cx="1965960" cy="594360"/>
+            <a:off x="9381744" y="4818888"/>
+            <a:ext cx="2624328" cy="594360"/>
           </a:xfrm>
         </p:spPr>
         <p:txBody>
@@ -11892,8 +11892,8 @@
         </p:nvSpPr>
         <p:spPr>
           <a:xfrm>
-            <a:off x="7022592" y="5486400"/>
-            <a:ext cx="1965960" cy="502920"/>
+            <a:off x="9381744" y="5486400"/>
+            <a:ext cx="2624328" cy="502920"/>
           </a:xfrm>
         </p:spPr>
         <p:txBody>
@@ -11941,8 +11941,8 @@
         </p:nvSpPr>
         <p:spPr>
           <a:xfrm>
-            <a:off x="182880" y="6492240"/>
-            <a:ext cx="8778240" cy="320040"/>
+            <a:off x="246888" y="6492240"/>
+            <a:ext cx="11704320" cy="320040"/>
           </a:xfrm>
         </p:spPr>
         <p:txBody>
@@ -12016,7 +12016,7 @@
         <p:spPr>
           <a:xfrm>
             <a:off x="0" y="0"/>
-            <a:ext cx="9144000" cy="6858000"/>
+            <a:ext cx="12192000" cy="6858000"/>
           </a:xfrm>
           <a:solidFill>
             <a:srgbClr val="1C2B4A">
@@ -12056,7 +12056,7 @@
         <p:spPr>
           <a:xfrm>
             <a:off x="0" y="0"/>
-            <a:ext cx="9144000" cy="822960"/>
+            <a:ext cx="12192000" cy="822960"/>
           </a:xfrm>
           <a:solidFill>
             <a:srgbClr val="F39C12">
@@ -12095,8 +12095,8 @@
         </p:nvSpPr>
         <p:spPr>
           <a:xfrm>
-            <a:off x="365760" y="91440"/>
-            <a:ext cx="8229600" cy="640080"/>
+            <a:off x="457200" y="91440"/>
+            <a:ext cx="11277600" cy="640080"/>
           </a:xfrm>
         </p:spPr>
         <p:txBody>
@@ -12144,8 +12144,8 @@
         </p:nvSpPr>
         <p:spPr>
           <a:xfrm>
-            <a:off x="274320" y="914400"/>
-            <a:ext cx="8686800" cy="411480"/>
+            <a:off x="365760" y="914400"/>
+            <a:ext cx="11457432" cy="411480"/>
           </a:xfrm>
         </p:spPr>
         <p:txBody>
@@ -12193,8 +12193,8 @@
         </p:nvSpPr>
         <p:spPr>
           <a:xfrm>
-            <a:off x="182880" y="1508760"/>
-            <a:ext cx="2834640" cy="2194560"/>
+            <a:off x="246888" y="1508760"/>
+            <a:ext cx="3776472" cy="2194560"/>
           </a:xfrm>
           <a:solidFill>
             <a:srgbClr val="1A2840">
@@ -12233,8 +12233,8 @@
         </p:nvSpPr>
         <p:spPr>
           <a:xfrm>
-            <a:off x="320040" y="1618488"/>
-            <a:ext cx="2651760" cy="502920"/>
+            <a:off x="429768" y="1618488"/>
+            <a:ext cx="3538728" cy="502920"/>
           </a:xfrm>
         </p:spPr>
         <p:txBody>
@@ -12282,8 +12282,8 @@
         </p:nvSpPr>
         <p:spPr>
           <a:xfrm>
-            <a:off x="320040" y="2167128"/>
-            <a:ext cx="2651760" cy="594360"/>
+            <a:off x="429768" y="2167128"/>
+            <a:ext cx="3538728" cy="594360"/>
           </a:xfrm>
         </p:spPr>
         <p:txBody>
@@ -12331,8 +12331,8 @@
         </p:nvSpPr>
         <p:spPr>
           <a:xfrm>
-            <a:off x="320040" y="2807208"/>
-            <a:ext cx="2651760" cy="640080"/>
+            <a:off x="429768" y="2807208"/>
+            <a:ext cx="3538728" cy="640080"/>
           </a:xfrm>
         </p:spPr>
         <p:txBody>
@@ -12380,8 +12380,8 @@
         </p:nvSpPr>
         <p:spPr>
           <a:xfrm>
-            <a:off x="3172968" y="1508760"/>
-            <a:ext cx="2834640" cy="2194560"/>
+            <a:off x="4233672" y="1508760"/>
+            <a:ext cx="3776472" cy="2194560"/>
           </a:xfrm>
           <a:solidFill>
             <a:srgbClr val="1A2840">
@@ -12420,8 +12420,8 @@
         </p:nvSpPr>
         <p:spPr>
           <a:xfrm>
-            <a:off x="3310128" y="1618488"/>
-            <a:ext cx="2651760" cy="502920"/>
+            <a:off x="4416552" y="1618488"/>
+            <a:ext cx="3538728" cy="502920"/>
           </a:xfrm>
         </p:spPr>
         <p:txBody>
@@ -12469,8 +12469,8 @@
         </p:nvSpPr>
         <p:spPr>
           <a:xfrm>
-            <a:off x="3310128" y="2167128"/>
-            <a:ext cx="2651760" cy="594360"/>
+            <a:off x="4416552" y="2167128"/>
+            <a:ext cx="3538728" cy="594360"/>
           </a:xfrm>
         </p:spPr>
         <p:txBody>
@@ -12518,8 +12518,8 @@
         </p:nvSpPr>
         <p:spPr>
           <a:xfrm>
-            <a:off x="3310128" y="2807208"/>
-            <a:ext cx="2651760" cy="640080"/>
+            <a:off x="4416552" y="2807208"/>
+            <a:ext cx="3538728" cy="640080"/>
           </a:xfrm>
         </p:spPr>
         <p:txBody>
@@ -12567,8 +12567,8 @@
         </p:nvSpPr>
         <p:spPr>
           <a:xfrm>
-            <a:off x="6163056" y="1508760"/>
-            <a:ext cx="2834640" cy="2194560"/>
+            <a:off x="8220456" y="1508760"/>
+            <a:ext cx="3776472" cy="2194560"/>
           </a:xfrm>
           <a:solidFill>
             <a:srgbClr val="1A2840">
@@ -12607,8 +12607,8 @@
         </p:nvSpPr>
         <p:spPr>
           <a:xfrm>
-            <a:off x="6300216" y="1618488"/>
-            <a:ext cx="2651760" cy="502920"/>
+            <a:off x="8403336" y="1618488"/>
+            <a:ext cx="3538728" cy="502920"/>
           </a:xfrm>
         </p:spPr>
         <p:txBody>
@@ -12656,8 +12656,8 @@
         </p:nvSpPr>
         <p:spPr>
           <a:xfrm>
-            <a:off x="6300216" y="2167128"/>
-            <a:ext cx="2651760" cy="594360"/>
+            <a:off x="8403336" y="2167128"/>
+            <a:ext cx="3538728" cy="594360"/>
           </a:xfrm>
         </p:spPr>
         <p:txBody>
@@ -12705,8 +12705,8 @@
         </p:nvSpPr>
         <p:spPr>
           <a:xfrm>
-            <a:off x="6300216" y="2807208"/>
-            <a:ext cx="2651760" cy="640080"/>
+            <a:off x="8403336" y="2807208"/>
+            <a:ext cx="3538728" cy="640080"/>
           </a:xfrm>
         </p:spPr>
         <p:txBody>
@@ -12754,8 +12754,8 @@
         </p:nvSpPr>
         <p:spPr>
           <a:xfrm>
-            <a:off x="182880" y="3886200"/>
-            <a:ext cx="2834640" cy="2194560"/>
+            <a:off x="246888" y="3886200"/>
+            <a:ext cx="3776472" cy="2194560"/>
           </a:xfrm>
           <a:solidFill>
             <a:srgbClr val="1A2840">
@@ -12794,8 +12794,8 @@
         </p:nvSpPr>
         <p:spPr>
           <a:xfrm>
-            <a:off x="320040" y="3995928"/>
-            <a:ext cx="2651760" cy="502920"/>
+            <a:off x="429768" y="3995928"/>
+            <a:ext cx="3538728" cy="502920"/>
           </a:xfrm>
         </p:spPr>
         <p:txBody>
@@ -12843,8 +12843,8 @@
         </p:nvSpPr>
         <p:spPr>
           <a:xfrm>
-            <a:off x="320040" y="4544568"/>
-            <a:ext cx="2651760" cy="594360"/>
+            <a:off x="429768" y="4544568"/>
+            <a:ext cx="3538728" cy="594360"/>
           </a:xfrm>
         </p:spPr>
         <p:txBody>
@@ -12892,8 +12892,8 @@
         </p:nvSpPr>
         <p:spPr>
           <a:xfrm>
-            <a:off x="320040" y="5184648"/>
-            <a:ext cx="2651760" cy="640080"/>
+            <a:off x="429768" y="5184648"/>
+            <a:ext cx="3538728" cy="640080"/>
           </a:xfrm>
         </p:spPr>
         <p:txBody>
@@ -12941,8 +12941,8 @@
         </p:nvSpPr>
         <p:spPr>
           <a:xfrm>
-            <a:off x="3172968" y="3886200"/>
-            <a:ext cx="2834640" cy="2194560"/>
+            <a:off x="4233672" y="3886200"/>
+            <a:ext cx="3776472" cy="2194560"/>
           </a:xfrm>
           <a:solidFill>
             <a:srgbClr val="1A2840">
@@ -12981,8 +12981,8 @@
         </p:nvSpPr>
         <p:spPr>
           <a:xfrm>
-            <a:off x="3310128" y="3995928"/>
-            <a:ext cx="2651760" cy="502920"/>
+            <a:off x="4416552" y="3995928"/>
+            <a:ext cx="3538728" cy="502920"/>
           </a:xfrm>
         </p:spPr>
         <p:txBody>
@@ -13030,8 +13030,8 @@
         </p:nvSpPr>
         <p:spPr>
           <a:xfrm>
-            <a:off x="3310128" y="4544568"/>
-            <a:ext cx="2651760" cy="594360"/>
+            <a:off x="4416552" y="4544568"/>
+            <a:ext cx="3538728" cy="594360"/>
           </a:xfrm>
         </p:spPr>
         <p:txBody>
@@ -13079,8 +13079,8 @@
         </p:nvSpPr>
         <p:spPr>
           <a:xfrm>
-            <a:off x="3310128" y="5184648"/>
-            <a:ext cx="2651760" cy="640080"/>
+            <a:off x="4416552" y="5184648"/>
+            <a:ext cx="3538728" cy="640080"/>
           </a:xfrm>
         </p:spPr>
         <p:txBody>
@@ -13128,8 +13128,8 @@
         </p:nvSpPr>
         <p:spPr>
           <a:xfrm>
-            <a:off x="6163056" y="3886200"/>
-            <a:ext cx="2834640" cy="2194560"/>
+            <a:off x="8220456" y="3886200"/>
+            <a:ext cx="3776472" cy="2194560"/>
           </a:xfrm>
           <a:solidFill>
             <a:srgbClr val="1A2840">
@@ -13168,8 +13168,8 @@
         </p:nvSpPr>
         <p:spPr>
           <a:xfrm>
-            <a:off x="6300216" y="3995928"/>
-            <a:ext cx="2651760" cy="502920"/>
+            <a:off x="8403336" y="3995928"/>
+            <a:ext cx="3538728" cy="502920"/>
           </a:xfrm>
         </p:spPr>
         <p:txBody>
@@ -13217,8 +13217,8 @@
         </p:nvSpPr>
         <p:spPr>
           <a:xfrm>
-            <a:off x="6300216" y="4544568"/>
-            <a:ext cx="2651760" cy="594360"/>
+            <a:off x="8403336" y="4544568"/>
+            <a:ext cx="3538728" cy="594360"/>
           </a:xfrm>
         </p:spPr>
         <p:txBody>
@@ -13266,8 +13266,8 @@
         </p:nvSpPr>
         <p:spPr>
           <a:xfrm>
-            <a:off x="6300216" y="5184648"/>
-            <a:ext cx="2651760" cy="640080"/>
+            <a:off x="8403336" y="5184648"/>
+            <a:ext cx="3538728" cy="640080"/>
           </a:xfrm>
         </p:spPr>
         <p:txBody>
@@ -13341,7 +13341,7 @@
         <p:spPr>
           <a:xfrm>
             <a:off x="0" y="0"/>
-            <a:ext cx="9144000" cy="6858000"/>
+            <a:ext cx="12192000" cy="6858000"/>
           </a:xfrm>
           <a:solidFill>
             <a:srgbClr val="1C2B4A">
@@ -13381,7 +13381,7 @@
         <p:spPr>
           <a:xfrm>
             <a:off x="0" y="0"/>
-            <a:ext cx="9144000" cy="822960"/>
+            <a:ext cx="12192000" cy="822960"/>
           </a:xfrm>
           <a:solidFill>
             <a:srgbClr val="1D9E75">
@@ -13420,8 +13420,8 @@
         </p:nvSpPr>
         <p:spPr>
           <a:xfrm>
-            <a:off x="365760" y="91440"/>
-            <a:ext cx="8229600" cy="640080"/>
+            <a:off x="457200" y="91440"/>
+            <a:ext cx="11277600" cy="640080"/>
           </a:xfrm>
         </p:spPr>
         <p:txBody>
@@ -13469,8 +13469,8 @@
         </p:nvSpPr>
         <p:spPr>
           <a:xfrm>
-            <a:off x="274320" y="868680"/>
-            <a:ext cx="8595360" cy="365760"/>
+            <a:off x="365760" y="868680"/>
+            <a:ext cx="11457432" cy="365760"/>
           </a:xfrm>
         </p:spPr>
         <p:txBody>
@@ -13518,8 +13518,8 @@
         </p:nvSpPr>
         <p:spPr>
           <a:xfrm>
-            <a:off x="137160" y="1325880"/>
-            <a:ext cx="1691640" cy="1463040"/>
+            <a:off x="182880" y="1325880"/>
+            <a:ext cx="2258568" cy="1463040"/>
           </a:xfrm>
           <a:solidFill>
             <a:srgbClr val="1A2840">
@@ -13558,8 +13558,8 @@
         </p:nvSpPr>
         <p:spPr>
           <a:xfrm>
-            <a:off x="182880" y="1389888"/>
-            <a:ext cx="1600200" cy="502920"/>
+            <a:off x="246888" y="1389888"/>
+            <a:ext cx="2130552" cy="502920"/>
           </a:xfrm>
         </p:spPr>
         <p:txBody>
@@ -13607,8 +13607,8 @@
         </p:nvSpPr>
         <p:spPr>
           <a:xfrm>
-            <a:off x="182880" y="1911096"/>
-            <a:ext cx="1600200" cy="320040"/>
+            <a:off x="246888" y="1911096"/>
+            <a:ext cx="2130552" cy="320040"/>
           </a:xfrm>
         </p:spPr>
         <p:txBody>
@@ -13656,8 +13656,8 @@
         </p:nvSpPr>
         <p:spPr>
           <a:xfrm>
-            <a:off x="182880" y="2231136"/>
-            <a:ext cx="1600200" cy="411480"/>
+            <a:off x="246888" y="2231136"/>
+            <a:ext cx="2130552" cy="411480"/>
           </a:xfrm>
         </p:spPr>
         <p:txBody>
@@ -13705,8 +13705,8 @@
         </p:nvSpPr>
         <p:spPr>
           <a:xfrm>
-            <a:off x="1938528" y="1325880"/>
-            <a:ext cx="1691640" cy="1463040"/>
+            <a:off x="2560320" y="1325880"/>
+            <a:ext cx="2258568" cy="1463040"/>
           </a:xfrm>
           <a:solidFill>
             <a:srgbClr val="1A2840">
@@ -13745,8 +13745,8 @@
         </p:nvSpPr>
         <p:spPr>
           <a:xfrm>
-            <a:off x="1984248" y="1389888"/>
-            <a:ext cx="1600200" cy="502920"/>
+            <a:off x="2624328" y="1389888"/>
+            <a:ext cx="2130552" cy="502920"/>
           </a:xfrm>
         </p:spPr>
         <p:txBody>
@@ -13794,8 +13794,8 @@
         </p:nvSpPr>
         <p:spPr>
           <a:xfrm>
-            <a:off x="1984248" y="1911096"/>
-            <a:ext cx="1600200" cy="320040"/>
+            <a:off x="2624328" y="1911096"/>
+            <a:ext cx="2130552" cy="320040"/>
           </a:xfrm>
         </p:spPr>
         <p:txBody>
@@ -13843,8 +13843,8 @@
         </p:nvSpPr>
         <p:spPr>
           <a:xfrm>
-            <a:off x="1984248" y="2231136"/>
-            <a:ext cx="1600200" cy="411480"/>
+            <a:off x="2624328" y="2231136"/>
+            <a:ext cx="2130552" cy="411480"/>
           </a:xfrm>
         </p:spPr>
         <p:txBody>
@@ -13892,8 +13892,8 @@
         </p:nvSpPr>
         <p:spPr>
           <a:xfrm>
-            <a:off x="3739896" y="1325880"/>
-            <a:ext cx="1691640" cy="1463040"/>
+            <a:off x="4937760" y="1325880"/>
+            <a:ext cx="2258568" cy="1463040"/>
           </a:xfrm>
           <a:solidFill>
             <a:srgbClr val="1A2840">
@@ -13932,8 +13932,8 @@
         </p:nvSpPr>
         <p:spPr>
           <a:xfrm>
-            <a:off x="3785616" y="1389888"/>
-            <a:ext cx="1600200" cy="502920"/>
+            <a:off x="5001768" y="1389888"/>
+            <a:ext cx="2130552" cy="502920"/>
           </a:xfrm>
         </p:spPr>
         <p:txBody>
@@ -13981,8 +13981,8 @@
         </p:nvSpPr>
         <p:spPr>
           <a:xfrm>
-            <a:off x="3785616" y="1911096"/>
-            <a:ext cx="1600200" cy="320040"/>
+            <a:off x="5001768" y="1911096"/>
+            <a:ext cx="2130552" cy="320040"/>
           </a:xfrm>
         </p:spPr>
         <p:txBody>
@@ -14030,8 +14030,8 @@
         </p:nvSpPr>
         <p:spPr>
           <a:xfrm>
-            <a:off x="3785616" y="2231136"/>
-            <a:ext cx="1600200" cy="411480"/>
+            <a:off x="5001768" y="2231136"/>
+            <a:ext cx="2130552" cy="411480"/>
           </a:xfrm>
         </p:spPr>
         <p:txBody>
@@ -14079,8 +14079,8 @@
         </p:nvSpPr>
         <p:spPr>
           <a:xfrm>
-            <a:off x="5541264" y="1325880"/>
-            <a:ext cx="1691640" cy="1463040"/>
+            <a:off x="7315200" y="1325880"/>
+            <a:ext cx="2258568" cy="1463040"/>
           </a:xfrm>
           <a:solidFill>
             <a:srgbClr val="1A2840">
@@ -14119,8 +14119,8 @@
         </p:nvSpPr>
         <p:spPr>
           <a:xfrm>
-            <a:off x="5586984" y="1389888"/>
-            <a:ext cx="1600200" cy="502920"/>
+            <a:off x="7379208" y="1389888"/>
+            <a:ext cx="2130552" cy="502920"/>
           </a:xfrm>
         </p:spPr>
         <p:txBody>
@@ -14168,8 +14168,8 @@
         </p:nvSpPr>
         <p:spPr>
           <a:xfrm>
-            <a:off x="5586984" y="1911096"/>
-            <a:ext cx="1600200" cy="320040"/>
+            <a:off x="7379208" y="1911096"/>
+            <a:ext cx="2130552" cy="320040"/>
           </a:xfrm>
         </p:spPr>
         <p:txBody>
@@ -14217,8 +14217,8 @@
         </p:nvSpPr>
         <p:spPr>
           <a:xfrm>
-            <a:off x="5586984" y="2231136"/>
-            <a:ext cx="1600200" cy="411480"/>
+            <a:off x="7379208" y="2231136"/>
+            <a:ext cx="2130552" cy="411480"/>
           </a:xfrm>
         </p:spPr>
         <p:txBody>
@@ -14266,8 +14266,8 @@
         </p:nvSpPr>
         <p:spPr>
           <a:xfrm>
-            <a:off x="7342632" y="1325880"/>
-            <a:ext cx="1691640" cy="1463040"/>
+            <a:off x="9692640" y="1325880"/>
+            <a:ext cx="2258568" cy="1463040"/>
           </a:xfrm>
           <a:solidFill>
             <a:srgbClr val="1A2840">
@@ -14306,8 +14306,8 @@
         </p:nvSpPr>
         <p:spPr>
           <a:xfrm>
-            <a:off x="7388352" y="1389888"/>
-            <a:ext cx="1600200" cy="502920"/>
+            <a:off x="9756648" y="1389888"/>
+            <a:ext cx="2130552" cy="502920"/>
           </a:xfrm>
         </p:spPr>
         <p:txBody>
@@ -14355,8 +14355,8 @@
         </p:nvSpPr>
         <p:spPr>
           <a:xfrm>
-            <a:off x="7388352" y="1911096"/>
-            <a:ext cx="1600200" cy="320040"/>
+            <a:off x="9756648" y="1911096"/>
+            <a:ext cx="2130552" cy="320040"/>
           </a:xfrm>
         </p:spPr>
         <p:txBody>
@@ -14404,8 +14404,8 @@
         </p:nvSpPr>
         <p:spPr>
           <a:xfrm>
-            <a:off x="7388352" y="2231136"/>
-            <a:ext cx="1600200" cy="411480"/>
+            <a:off x="9756648" y="2231136"/>
+            <a:ext cx="2130552" cy="411480"/>
           </a:xfrm>
         </p:spPr>
         <p:txBody>
@@ -14453,8 +14453,8 @@
         </p:nvSpPr>
         <p:spPr>
           <a:xfrm>
-            <a:off x="274320" y="2971800"/>
-            <a:ext cx="8595360" cy="384048"/>
+            <a:off x="365760" y="2971800"/>
+            <a:ext cx="11457432" cy="384048"/>
           </a:xfrm>
         </p:spPr>
         <p:txBody>
@@ -14502,8 +14502,8 @@
         </p:nvSpPr>
         <p:spPr>
           <a:xfrm>
-            <a:off x="228600" y="3383280"/>
-            <a:ext cx="1005840" cy="347472"/>
+            <a:off x="365760" y="3383280"/>
+            <a:ext cx="1216152" cy="347472"/>
           </a:xfrm>
           <a:solidFill>
             <a:srgbClr val="0D1F3C">
@@ -14542,8 +14542,8 @@
         </p:nvSpPr>
         <p:spPr>
           <a:xfrm>
-            <a:off x="256032" y="3410712"/>
-            <a:ext cx="950976" cy="292608"/>
+            <a:off x="402336" y="3410712"/>
+            <a:ext cx="1143000" cy="292608"/>
           </a:xfrm>
         </p:spPr>
         <p:txBody>
@@ -14591,8 +14591,8 @@
         </p:nvSpPr>
         <p:spPr>
           <a:xfrm>
-            <a:off x="1234440" y="3383280"/>
-            <a:ext cx="1353312" cy="347472"/>
+            <a:off x="1581912" y="3383280"/>
+            <a:ext cx="1709928" cy="347472"/>
           </a:xfrm>
           <a:solidFill>
             <a:srgbClr val="0D1F3C">
@@ -14631,8 +14631,8 @@
         </p:nvSpPr>
         <p:spPr>
           <a:xfrm>
-            <a:off x="1261872" y="3410712"/>
-            <a:ext cx="1298448" cy="292608"/>
+            <a:off x="1618488" y="3410712"/>
+            <a:ext cx="1636776" cy="292608"/>
           </a:xfrm>
         </p:spPr>
         <p:txBody>
@@ -14680,8 +14680,8 @@
         </p:nvSpPr>
         <p:spPr>
           <a:xfrm>
-            <a:off x="2587752" y="3383280"/>
-            <a:ext cx="1353312" cy="347472"/>
+            <a:off x="3291840" y="3383280"/>
+            <a:ext cx="1709928" cy="347472"/>
           </a:xfrm>
           <a:solidFill>
             <a:srgbClr val="0D1F3C">
@@ -14720,8 +14720,8 @@
         </p:nvSpPr>
         <p:spPr>
           <a:xfrm>
-            <a:off x="2615184" y="3410712"/>
-            <a:ext cx="1298448" cy="292608"/>
+            <a:off x="3328416" y="3410712"/>
+            <a:ext cx="1636776" cy="292608"/>
           </a:xfrm>
         </p:spPr>
         <p:txBody>
@@ -14769,8 +14769,8 @@
         </p:nvSpPr>
         <p:spPr>
           <a:xfrm>
-            <a:off x="3941064" y="3383280"/>
-            <a:ext cx="1353312" cy="347472"/>
+            <a:off x="5001768" y="3383280"/>
+            <a:ext cx="1709928" cy="347472"/>
           </a:xfrm>
           <a:solidFill>
             <a:srgbClr val="0D1F3C">
@@ -14809,8 +14809,8 @@
         </p:nvSpPr>
         <p:spPr>
           <a:xfrm>
-            <a:off x="3968496" y="3410712"/>
-            <a:ext cx="1298448" cy="292608"/>
+            <a:off x="5038344" y="3410712"/>
+            <a:ext cx="1636776" cy="292608"/>
           </a:xfrm>
         </p:spPr>
         <p:txBody>
@@ -14858,8 +14858,8 @@
         </p:nvSpPr>
         <p:spPr>
           <a:xfrm>
-            <a:off x="5294376" y="3383280"/>
-            <a:ext cx="1353312" cy="347472"/>
+            <a:off x="6711696" y="3383280"/>
+            <a:ext cx="1709928" cy="347472"/>
           </a:xfrm>
           <a:solidFill>
             <a:srgbClr val="0D1F3C">
@@ -14898,8 +14898,8 @@
         </p:nvSpPr>
         <p:spPr>
           <a:xfrm>
-            <a:off x="5321808" y="3410712"/>
-            <a:ext cx="1298448" cy="292608"/>
+            <a:off x="6748272" y="3410712"/>
+            <a:ext cx="1636776" cy="292608"/>
           </a:xfrm>
         </p:spPr>
         <p:txBody>
@@ -14947,8 +14947,8 @@
         </p:nvSpPr>
         <p:spPr>
           <a:xfrm>
-            <a:off x="6647688" y="3383280"/>
-            <a:ext cx="1353312" cy="347472"/>
+            <a:off x="8421624" y="3383280"/>
+            <a:ext cx="1709928" cy="347472"/>
           </a:xfrm>
           <a:solidFill>
             <a:srgbClr val="0D1F3C">
@@ -14987,8 +14987,8 @@
         </p:nvSpPr>
         <p:spPr>
           <a:xfrm>
-            <a:off x="6675120" y="3410712"/>
-            <a:ext cx="1298448" cy="292608"/>
+            <a:off x="8458200" y="3410712"/>
+            <a:ext cx="1636776" cy="292608"/>
           </a:xfrm>
         </p:spPr>
         <p:txBody>
@@ -15036,8 +15036,8 @@
         </p:nvSpPr>
         <p:spPr>
           <a:xfrm>
-            <a:off x="8001000" y="3383280"/>
-            <a:ext cx="1353312" cy="347472"/>
+            <a:off x="10131552" y="3383280"/>
+            <a:ext cx="1709928" cy="347472"/>
           </a:xfrm>
           <a:solidFill>
             <a:srgbClr val="0D1F3C">
@@ -15076,8 +15076,8 @@
         </p:nvSpPr>
         <p:spPr>
           <a:xfrm>
-            <a:off x="8028432" y="3410712"/>
-            <a:ext cx="1298448" cy="292608"/>
+            <a:off x="10168128" y="3410712"/>
+            <a:ext cx="1636776" cy="292608"/>
           </a:xfrm>
         </p:spPr>
         <p:txBody>
@@ -15125,8 +15125,8 @@
         </p:nvSpPr>
         <p:spPr>
           <a:xfrm>
-            <a:off x="228600" y="3749040"/>
-            <a:ext cx="1005840" cy="521208"/>
+            <a:off x="365760" y="3749040"/>
+            <a:ext cx="1216152" cy="521208"/>
           </a:xfrm>
           <a:solidFill>
             <a:srgbClr val="2A2A1A">
@@ -15165,8 +15165,8 @@
         </p:nvSpPr>
         <p:spPr>
           <a:xfrm>
-            <a:off x="256032" y="3840480"/>
-            <a:ext cx="950976" cy="347472"/>
+            <a:off x="402336" y="3840480"/>
+            <a:ext cx="1143000" cy="347472"/>
           </a:xfrm>
         </p:spPr>
         <p:txBody>
@@ -15214,8 +15214,8 @@
         </p:nvSpPr>
         <p:spPr>
           <a:xfrm>
-            <a:off x="1234440" y="3749040"/>
-            <a:ext cx="1353312" cy="521208"/>
+            <a:off x="1581912" y="3749040"/>
+            <a:ext cx="1709928" cy="521208"/>
           </a:xfrm>
           <a:solidFill>
             <a:srgbClr val="2A2A1A">
@@ -15254,8 +15254,8 @@
         </p:nvSpPr>
         <p:spPr>
           <a:xfrm>
-            <a:off x="1261872" y="3840480"/>
-            <a:ext cx="1298448" cy="347472"/>
+            <a:off x="1618488" y="3840480"/>
+            <a:ext cx="1636776" cy="347472"/>
           </a:xfrm>
         </p:spPr>
         <p:txBody>
@@ -15303,8 +15303,8 @@
         </p:nvSpPr>
         <p:spPr>
           <a:xfrm>
-            <a:off x="2587752" y="3749040"/>
-            <a:ext cx="1353312" cy="521208"/>
+            <a:off x="3291840" y="3749040"/>
+            <a:ext cx="1709928" cy="521208"/>
           </a:xfrm>
           <a:solidFill>
             <a:srgbClr val="2A2A1A">
@@ -15343,8 +15343,8 @@
         </p:nvSpPr>
         <p:spPr>
           <a:xfrm>
-            <a:off x="2615184" y="3840480"/>
-            <a:ext cx="1298448" cy="347472"/>
+            <a:off x="3328416" y="3840480"/>
+            <a:ext cx="1636776" cy="347472"/>
           </a:xfrm>
         </p:spPr>
         <p:txBody>
@@ -15392,8 +15392,8 @@
         </p:nvSpPr>
         <p:spPr>
           <a:xfrm>
-            <a:off x="3941064" y="3749040"/>
-            <a:ext cx="1353312" cy="521208"/>
+            <a:off x="5001768" y="3749040"/>
+            <a:ext cx="1709928" cy="521208"/>
           </a:xfrm>
           <a:solidFill>
             <a:srgbClr val="2A2A1A">
@@ -15432,8 +15432,8 @@
         </p:nvSpPr>
         <p:spPr>
           <a:xfrm>
-            <a:off x="3968496" y="3840480"/>
-            <a:ext cx="1298448" cy="347472"/>
+            <a:off x="5038344" y="3840480"/>
+            <a:ext cx="1636776" cy="347472"/>
           </a:xfrm>
         </p:spPr>
         <p:txBody>
@@ -15481,8 +15481,8 @@
         </p:nvSpPr>
         <p:spPr>
           <a:xfrm>
-            <a:off x="5294376" y="3749040"/>
-            <a:ext cx="1353312" cy="521208"/>
+            <a:off x="6711696" y="3749040"/>
+            <a:ext cx="1709928" cy="521208"/>
           </a:xfrm>
           <a:solidFill>
             <a:srgbClr val="2A2A1A">
@@ -15521,8 +15521,8 @@
         </p:nvSpPr>
         <p:spPr>
           <a:xfrm>
-            <a:off x="5321808" y="3840480"/>
-            <a:ext cx="1298448" cy="347472"/>
+            <a:off x="6748272" y="3840480"/>
+            <a:ext cx="1636776" cy="347472"/>
           </a:xfrm>
         </p:spPr>
         <p:txBody>
@@ -15570,8 +15570,8 @@
         </p:nvSpPr>
         <p:spPr>
           <a:xfrm>
-            <a:off x="6647688" y="3749040"/>
-            <a:ext cx="1353312" cy="521208"/>
+            <a:off x="8421624" y="3749040"/>
+            <a:ext cx="1709928" cy="521208"/>
           </a:xfrm>
           <a:solidFill>
             <a:srgbClr val="2A2A1A">
@@ -15610,8 +15610,8 @@
         </p:nvSpPr>
         <p:spPr>
           <a:xfrm>
-            <a:off x="6675120" y="3840480"/>
-            <a:ext cx="1298448" cy="347472"/>
+            <a:off x="8458200" y="3840480"/>
+            <a:ext cx="1636776" cy="347472"/>
           </a:xfrm>
         </p:spPr>
         <p:txBody>
@@ -15659,8 +15659,8 @@
         </p:nvSpPr>
         <p:spPr>
           <a:xfrm>
-            <a:off x="8001000" y="3749040"/>
-            <a:ext cx="1353312" cy="521208"/>
+            <a:off x="10131552" y="3749040"/>
+            <a:ext cx="1709928" cy="521208"/>
           </a:xfrm>
           <a:solidFill>
             <a:srgbClr val="2A2A1A">
@@ -15699,8 +15699,8 @@
         </p:nvSpPr>
         <p:spPr>
           <a:xfrm>
-            <a:off x="8028432" y="3840480"/>
-            <a:ext cx="1298448" cy="347472"/>
+            <a:off x="10168128" y="3840480"/>
+            <a:ext cx="1636776" cy="347472"/>
           </a:xfrm>
         </p:spPr>
         <p:txBody>
@@ -15748,8 +15748,8 @@
         </p:nvSpPr>
         <p:spPr>
           <a:xfrm>
-            <a:off x="228600" y="4315968"/>
-            <a:ext cx="1005840" cy="521208"/>
+            <a:off x="365760" y="4315968"/>
+            <a:ext cx="1216152" cy="521208"/>
           </a:xfrm>
           <a:solidFill>
             <a:srgbClr val="1A2A3A">
@@ -15788,8 +15788,8 @@
         </p:nvSpPr>
         <p:spPr>
           <a:xfrm>
-            <a:off x="256032" y="4407408"/>
-            <a:ext cx="950976" cy="347472"/>
+            <a:off x="402336" y="4407408"/>
+            <a:ext cx="1143000" cy="347472"/>
           </a:xfrm>
         </p:spPr>
         <p:txBody>
@@ -15837,8 +15837,8 @@
         </p:nvSpPr>
         <p:spPr>
           <a:xfrm>
-            <a:off x="1234440" y="4315968"/>
-            <a:ext cx="1353312" cy="521208"/>
+            <a:off x="1581912" y="4315968"/>
+            <a:ext cx="1709928" cy="521208"/>
           </a:xfrm>
           <a:solidFill>
             <a:srgbClr val="1A2A3A">
@@ -15877,8 +15877,8 @@
         </p:nvSpPr>
         <p:spPr>
           <a:xfrm>
-            <a:off x="1261872" y="4407408"/>
-            <a:ext cx="1298448" cy="347472"/>
+            <a:off x="1618488" y="4407408"/>
+            <a:ext cx="1636776" cy="347472"/>
           </a:xfrm>
         </p:spPr>
         <p:txBody>
@@ -15926,8 +15926,8 @@
         </p:nvSpPr>
         <p:spPr>
           <a:xfrm>
-            <a:off x="2587752" y="4315968"/>
-            <a:ext cx="1353312" cy="521208"/>
+            <a:off x="3291840" y="4315968"/>
+            <a:ext cx="1709928" cy="521208"/>
           </a:xfrm>
           <a:solidFill>
             <a:srgbClr val="1A2A3A">
@@ -15966,8 +15966,8 @@
         </p:nvSpPr>
         <p:spPr>
           <a:xfrm>
-            <a:off x="2615184" y="4407408"/>
-            <a:ext cx="1298448" cy="347472"/>
+            <a:off x="3328416" y="4407408"/>
+            <a:ext cx="1636776" cy="347472"/>
           </a:xfrm>
         </p:spPr>
         <p:txBody>
@@ -16015,8 +16015,8 @@
         </p:nvSpPr>
         <p:spPr>
           <a:xfrm>
-            <a:off x="3941064" y="4315968"/>
-            <a:ext cx="1353312" cy="521208"/>
+            <a:off x="5001768" y="4315968"/>
+            <a:ext cx="1709928" cy="521208"/>
           </a:xfrm>
           <a:solidFill>
             <a:srgbClr val="1A2A3A">
@@ -16055,8 +16055,8 @@
         </p:nvSpPr>
         <p:spPr>
           <a:xfrm>
-            <a:off x="3968496" y="4407408"/>
-            <a:ext cx="1298448" cy="347472"/>
+            <a:off x="5038344" y="4407408"/>
+            <a:ext cx="1636776" cy="347472"/>
           </a:xfrm>
         </p:spPr>
         <p:txBody>
@@ -16104,8 +16104,8 @@
         </p:nvSpPr>
         <p:spPr>
           <a:xfrm>
-            <a:off x="5294376" y="4315968"/>
-            <a:ext cx="1353312" cy="521208"/>
+            <a:off x="6711696" y="4315968"/>
+            <a:ext cx="1709928" cy="521208"/>
           </a:xfrm>
           <a:solidFill>
             <a:srgbClr val="1A2A3A">
@@ -16144,8 +16144,8 @@
         </p:nvSpPr>
         <p:spPr>
           <a:xfrm>
-            <a:off x="5321808" y="4407408"/>
-            <a:ext cx="1298448" cy="347472"/>
+            <a:off x="6748272" y="4407408"/>
+            <a:ext cx="1636776" cy="347472"/>
           </a:xfrm>
         </p:spPr>
         <p:txBody>
@@ -16193,8 +16193,8 @@
         </p:nvSpPr>
         <p:spPr>
           <a:xfrm>
-            <a:off x="6647688" y="4315968"/>
-            <a:ext cx="1353312" cy="521208"/>
+            <a:off x="8421624" y="4315968"/>
+            <a:ext cx="1709928" cy="521208"/>
           </a:xfrm>
           <a:solidFill>
             <a:srgbClr val="1A2A3A">
@@ -16233,8 +16233,8 @@
         </p:nvSpPr>
         <p:spPr>
           <a:xfrm>
-            <a:off x="6675120" y="4407408"/>
-            <a:ext cx="1298448" cy="347472"/>
+            <a:off x="8458200" y="4407408"/>
+            <a:ext cx="1636776" cy="347472"/>
           </a:xfrm>
         </p:spPr>
         <p:txBody>
@@ -16282,8 +16282,8 @@
         </p:nvSpPr>
         <p:spPr>
           <a:xfrm>
-            <a:off x="8001000" y="4315968"/>
-            <a:ext cx="1353312" cy="521208"/>
+            <a:off x="10131552" y="4315968"/>
+            <a:ext cx="1709928" cy="521208"/>
           </a:xfrm>
           <a:solidFill>
             <a:srgbClr val="1A2A3A">
@@ -16322,8 +16322,8 @@
         </p:nvSpPr>
         <p:spPr>
           <a:xfrm>
-            <a:off x="8028432" y="4407408"/>
-            <a:ext cx="1298448" cy="347472"/>
+            <a:off x="10168128" y="4407408"/>
+            <a:ext cx="1636776" cy="347472"/>
           </a:xfrm>
         </p:spPr>
         <p:txBody>
@@ -16371,8 +16371,8 @@
         </p:nvSpPr>
         <p:spPr>
           <a:xfrm>
-            <a:off x="228600" y="4882896"/>
-            <a:ext cx="1005840" cy="521208"/>
+            <a:off x="365760" y="4882896"/>
+            <a:ext cx="1216152" cy="521208"/>
           </a:xfrm>
           <a:solidFill>
             <a:srgbClr val="1A3A2A">
@@ -16411,8 +16411,8 @@
         </p:nvSpPr>
         <p:spPr>
           <a:xfrm>
-            <a:off x="256032" y="4974336"/>
-            <a:ext cx="950976" cy="347472"/>
+            <a:off x="402336" y="4974336"/>
+            <a:ext cx="1143000" cy="347472"/>
           </a:xfrm>
         </p:spPr>
         <p:txBody>
@@ -16460,8 +16460,8 @@
         </p:nvSpPr>
         <p:spPr>
           <a:xfrm>
-            <a:off x="1234440" y="4882896"/>
-            <a:ext cx="1353312" cy="521208"/>
+            <a:off x="1581912" y="4882896"/>
+            <a:ext cx="1709928" cy="521208"/>
           </a:xfrm>
           <a:solidFill>
             <a:srgbClr val="1A3A2A">
@@ -16500,8 +16500,8 @@
         </p:nvSpPr>
         <p:spPr>
           <a:xfrm>
-            <a:off x="1261872" y="4974336"/>
-            <a:ext cx="1298448" cy="347472"/>
+            <a:off x="1618488" y="4974336"/>
+            <a:ext cx="1636776" cy="347472"/>
           </a:xfrm>
         </p:spPr>
         <p:txBody>
@@ -16549,8 +16549,8 @@
         </p:nvSpPr>
         <p:spPr>
           <a:xfrm>
-            <a:off x="2587752" y="4882896"/>
-            <a:ext cx="1353312" cy="521208"/>
+            <a:off x="3291840" y="4882896"/>
+            <a:ext cx="1709928" cy="521208"/>
           </a:xfrm>
           <a:solidFill>
             <a:srgbClr val="1A3A2A">
@@ -16589,8 +16589,8 @@
         </p:nvSpPr>
         <p:spPr>
           <a:xfrm>
-            <a:off x="2615184" y="4974336"/>
-            <a:ext cx="1298448" cy="347472"/>
+            <a:off x="3328416" y="4974336"/>
+            <a:ext cx="1636776" cy="347472"/>
           </a:xfrm>
         </p:spPr>
         <p:txBody>
@@ -16638,8 +16638,8 @@
         </p:nvSpPr>
         <p:spPr>
           <a:xfrm>
-            <a:off x="3941064" y="4882896"/>
-            <a:ext cx="1353312" cy="521208"/>
+            <a:off x="5001768" y="4882896"/>
+            <a:ext cx="1709928" cy="521208"/>
           </a:xfrm>
           <a:solidFill>
             <a:srgbClr val="1A3A2A">
@@ -16678,8 +16678,8 @@
         </p:nvSpPr>
         <p:spPr>
           <a:xfrm>
-            <a:off x="3968496" y="4974336"/>
-            <a:ext cx="1298448" cy="347472"/>
+            <a:off x="5038344" y="4974336"/>
+            <a:ext cx="1636776" cy="347472"/>
           </a:xfrm>
         </p:spPr>
         <p:txBody>
@@ -16727,8 +16727,8 @@
         </p:nvSpPr>
         <p:spPr>
           <a:xfrm>
-            <a:off x="5294376" y="4882896"/>
-            <a:ext cx="1353312" cy="521208"/>
+            <a:off x="6711696" y="4882896"/>
+            <a:ext cx="1709928" cy="521208"/>
           </a:xfrm>
           <a:solidFill>
             <a:srgbClr val="1A3A2A">
@@ -16767,8 +16767,8 @@
         </p:nvSpPr>
         <p:spPr>
           <a:xfrm>
-            <a:off x="5321808" y="4974336"/>
-            <a:ext cx="1298448" cy="347472"/>
+            <a:off x="6748272" y="4974336"/>
+            <a:ext cx="1636776" cy="347472"/>
           </a:xfrm>
         </p:spPr>
         <p:txBody>
@@ -16816,8 +16816,8 @@
         </p:nvSpPr>
         <p:spPr>
           <a:xfrm>
-            <a:off x="6647688" y="4882896"/>
-            <a:ext cx="1353312" cy="521208"/>
+            <a:off x="8421624" y="4882896"/>
+            <a:ext cx="1709928" cy="521208"/>
           </a:xfrm>
           <a:solidFill>
             <a:srgbClr val="1A3A2A">
@@ -16856,8 +16856,8 @@
         </p:nvSpPr>
         <p:spPr>
           <a:xfrm>
-            <a:off x="6675120" y="4974336"/>
-            <a:ext cx="1298448" cy="347472"/>
+            <a:off x="8458200" y="4974336"/>
+            <a:ext cx="1636776" cy="347472"/>
           </a:xfrm>
         </p:spPr>
         <p:txBody>
@@ -16905,8 +16905,8 @@
         </p:nvSpPr>
         <p:spPr>
           <a:xfrm>
-            <a:off x="8001000" y="4882896"/>
-            <a:ext cx="1353312" cy="521208"/>
+            <a:off x="10131552" y="4882896"/>
+            <a:ext cx="1709928" cy="521208"/>
           </a:xfrm>
           <a:solidFill>
             <a:srgbClr val="1A3A2A">
@@ -16945,8 +16945,8 @@
         </p:nvSpPr>
         <p:spPr>
           <a:xfrm>
-            <a:off x="8028432" y="4974336"/>
-            <a:ext cx="1298448" cy="347472"/>
+            <a:off x="10168128" y="4974336"/>
+            <a:ext cx="1636776" cy="347472"/>
           </a:xfrm>
         </p:spPr>
         <p:txBody>
@@ -16994,8 +16994,8 @@
         </p:nvSpPr>
         <p:spPr>
           <a:xfrm>
-            <a:off x="228600" y="5486400"/>
-            <a:ext cx="8686800" cy="320040"/>
+            <a:off x="301752" y="5486400"/>
+            <a:ext cx="11585448" cy="320040"/>
           </a:xfrm>
         </p:spPr>
         <p:txBody>
@@ -17043,8 +17043,8 @@
         </p:nvSpPr>
         <p:spPr>
           <a:xfrm>
-            <a:off x="228600" y="5852160"/>
-            <a:ext cx="8686800" cy="320040"/>
+            <a:off x="301752" y="5852160"/>
+            <a:ext cx="11585448" cy="320040"/>
           </a:xfrm>
         </p:spPr>
         <p:txBody>
@@ -17118,7 +17118,7 @@
         <p:spPr>
           <a:xfrm>
             <a:off x="0" y="0"/>
-            <a:ext cx="9144000" cy="6858000"/>
+            <a:ext cx="12192000" cy="6858000"/>
           </a:xfrm>
           <a:solidFill>
             <a:srgbClr val="1C2B4A">
@@ -17158,7 +17158,7 @@
         <p:spPr>
           <a:xfrm>
             <a:off x="0" y="0"/>
-            <a:ext cx="9144000" cy="822960"/>
+            <a:ext cx="12192000" cy="822960"/>
           </a:xfrm>
           <a:solidFill>
             <a:srgbClr val="3DC494">
@@ -17197,8 +17197,8 @@
         </p:nvSpPr>
         <p:spPr>
           <a:xfrm>
-            <a:off x="365760" y="91440"/>
-            <a:ext cx="8229600" cy="640080"/>
+            <a:off x="457200" y="91440"/>
+            <a:ext cx="11277600" cy="640080"/>
           </a:xfrm>
         </p:spPr>
         <p:txBody>
@@ -17246,8 +17246,8 @@
         </p:nvSpPr>
         <p:spPr>
           <a:xfrm>
-            <a:off x="274320" y="914400"/>
-            <a:ext cx="8595360" cy="502920"/>
+            <a:off x="365760" y="914400"/>
+            <a:ext cx="11457432" cy="502920"/>
           </a:xfrm>
           <a:solidFill>
             <a:srgbClr val="0D2A1E">
@@ -17286,8 +17286,8 @@
         </p:nvSpPr>
         <p:spPr>
           <a:xfrm>
-            <a:off x="274320" y="978408"/>
-            <a:ext cx="8595360" cy="365760"/>
+            <a:off x="365760" y="978408"/>
+            <a:ext cx="11457432" cy="365760"/>
           </a:xfrm>
         </p:spPr>
         <p:txBody>
@@ -17335,8 +17335,8 @@
         </p:nvSpPr>
         <p:spPr>
           <a:xfrm>
-            <a:off x="182880" y="1508760"/>
-            <a:ext cx="1691640" cy="4983480"/>
+            <a:off x="246888" y="1508760"/>
+            <a:ext cx="2258568" cy="4983480"/>
           </a:xfrm>
           <a:solidFill>
             <a:srgbClr val="1A2840">
@@ -17375,8 +17375,8 @@
         </p:nvSpPr>
         <p:spPr>
           <a:xfrm>
-            <a:off x="274320" y="1554480"/>
-            <a:ext cx="1508760" cy="54864"/>
+            <a:off x="365760" y="1554480"/>
+            <a:ext cx="2011680" cy="54864"/>
           </a:xfrm>
           <a:solidFill>
             <a:srgbClr val="1D9E75">
@@ -17415,8 +17415,8 @@
         </p:nvSpPr>
         <p:spPr>
           <a:xfrm>
-            <a:off x="228600" y="1627632"/>
-            <a:ext cx="1600200" cy="292608"/>
+            <a:off x="310896" y="1627632"/>
+            <a:ext cx="2130552" cy="292608"/>
           </a:xfrm>
         </p:spPr>
         <p:txBody>
@@ -17464,8 +17464,8 @@
         </p:nvSpPr>
         <p:spPr>
           <a:xfrm>
-            <a:off x="228600" y="1938528"/>
-            <a:ext cx="1600200" cy="457200"/>
+            <a:off x="310896" y="1938528"/>
+            <a:ext cx="2130552" cy="457200"/>
           </a:xfrm>
         </p:spPr>
         <p:txBody>
@@ -17513,8 +17513,8 @@
         </p:nvSpPr>
         <p:spPr>
           <a:xfrm>
-            <a:off x="292608" y="2468880"/>
-            <a:ext cx="1508760" cy="3840480"/>
+            <a:off x="393192" y="2468880"/>
+            <a:ext cx="2011680" cy="3840480"/>
           </a:xfrm>
         </p:spPr>
         <p:txBody>
@@ -17646,8 +17646,8 @@
         </p:nvSpPr>
         <p:spPr>
           <a:xfrm>
-            <a:off x="1965960" y="1508760"/>
-            <a:ext cx="1691640" cy="4983480"/>
+            <a:off x="2624328" y="1508760"/>
+            <a:ext cx="2258568" cy="4983480"/>
           </a:xfrm>
           <a:solidFill>
             <a:srgbClr val="1A2840">
@@ -17686,8 +17686,8 @@
         </p:nvSpPr>
         <p:spPr>
           <a:xfrm>
-            <a:off x="2057400" y="1554480"/>
-            <a:ext cx="1508760" cy="54864"/>
+            <a:off x="2743200" y="1554480"/>
+            <a:ext cx="2011680" cy="54864"/>
           </a:xfrm>
           <a:solidFill>
             <a:srgbClr val="378ADD">
@@ -17726,8 +17726,8 @@
         </p:nvSpPr>
         <p:spPr>
           <a:xfrm>
-            <a:off x="2011680" y="1627632"/>
-            <a:ext cx="1600200" cy="292608"/>
+            <a:off x="2688336" y="1627632"/>
+            <a:ext cx="2130552" cy="292608"/>
           </a:xfrm>
         </p:spPr>
         <p:txBody>
@@ -17775,8 +17775,8 @@
         </p:nvSpPr>
         <p:spPr>
           <a:xfrm>
-            <a:off x="2011680" y="1938528"/>
-            <a:ext cx="1600200" cy="457200"/>
+            <a:off x="2688336" y="1938528"/>
+            <a:ext cx="2130552" cy="457200"/>
           </a:xfrm>
         </p:spPr>
         <p:txBody>
@@ -17824,8 +17824,8 @@
         </p:nvSpPr>
         <p:spPr>
           <a:xfrm>
-            <a:off x="2075688" y="2468880"/>
-            <a:ext cx="1508760" cy="3840480"/>
+            <a:off x="2770632" y="2468880"/>
+            <a:ext cx="2011680" cy="3840480"/>
           </a:xfrm>
         </p:spPr>
         <p:txBody>
@@ -17957,8 +17957,8 @@
         </p:nvSpPr>
         <p:spPr>
           <a:xfrm>
-            <a:off x="3749040" y="1508760"/>
-            <a:ext cx="1691640" cy="4983480"/>
+            <a:off x="5001768" y="1508760"/>
+            <a:ext cx="2258568" cy="4983480"/>
           </a:xfrm>
           <a:solidFill>
             <a:srgbClr val="1A2840">
@@ -17997,8 +17997,8 @@
         </p:nvSpPr>
         <p:spPr>
           <a:xfrm>
-            <a:off x="3840480" y="1554480"/>
-            <a:ext cx="1508760" cy="54864"/>
+            <a:off x="5120640" y="1554480"/>
+            <a:ext cx="2011680" cy="54864"/>
           </a:xfrm>
           <a:solidFill>
             <a:srgbClr val="F39C12">
@@ -18037,8 +18037,8 @@
         </p:nvSpPr>
         <p:spPr>
           <a:xfrm>
-            <a:off x="3794760" y="1627632"/>
-            <a:ext cx="1600200" cy="292608"/>
+            <a:off x="5065776" y="1627632"/>
+            <a:ext cx="2130552" cy="292608"/>
           </a:xfrm>
         </p:spPr>
         <p:txBody>
@@ -18086,8 +18086,8 @@
         </p:nvSpPr>
         <p:spPr>
           <a:xfrm>
-            <a:off x="3794760" y="1938528"/>
-            <a:ext cx="1600200" cy="457200"/>
+            <a:off x="5065776" y="1938528"/>
+            <a:ext cx="2130552" cy="457200"/>
           </a:xfrm>
         </p:spPr>
         <p:txBody>
@@ -18135,8 +18135,8 @@
         </p:nvSpPr>
         <p:spPr>
           <a:xfrm>
-            <a:off x="3858768" y="2468880"/>
-            <a:ext cx="1508760" cy="3840480"/>
+            <a:off x="5148072" y="2468880"/>
+            <a:ext cx="2011680" cy="3840480"/>
           </a:xfrm>
         </p:spPr>
         <p:txBody>
@@ -18268,8 +18268,8 @@
         </p:nvSpPr>
         <p:spPr>
           <a:xfrm>
-            <a:off x="5532120" y="1508760"/>
-            <a:ext cx="1691640" cy="4983480"/>
+            <a:off x="7379208" y="1508760"/>
+            <a:ext cx="2258568" cy="4983480"/>
           </a:xfrm>
           <a:solidFill>
             <a:srgbClr val="1A2840">
@@ -18308,8 +18308,8 @@
         </p:nvSpPr>
         <p:spPr>
           <a:xfrm>
-            <a:off x="5623560" y="1554480"/>
-            <a:ext cx="1508760" cy="54864"/>
+            <a:off x="7498080" y="1554480"/>
+            <a:ext cx="2011680" cy="54864"/>
           </a:xfrm>
           <a:solidFill>
             <a:srgbClr val="3DC494">
@@ -18348,8 +18348,8 @@
         </p:nvSpPr>
         <p:spPr>
           <a:xfrm>
-            <a:off x="5577840" y="1627632"/>
-            <a:ext cx="1600200" cy="292608"/>
+            <a:off x="7443216" y="1627632"/>
+            <a:ext cx="2130552" cy="292608"/>
           </a:xfrm>
         </p:spPr>
         <p:txBody>
@@ -18397,8 +18397,8 @@
         </p:nvSpPr>
         <p:spPr>
           <a:xfrm>
-            <a:off x="5577840" y="1938528"/>
-            <a:ext cx="1600200" cy="457200"/>
+            <a:off x="7443216" y="1938528"/>
+            <a:ext cx="2130552" cy="457200"/>
           </a:xfrm>
         </p:spPr>
         <p:txBody>
@@ -18446,8 +18446,8 @@
         </p:nvSpPr>
         <p:spPr>
           <a:xfrm>
-            <a:off x="5641848" y="2468880"/>
-            <a:ext cx="1508760" cy="3840480"/>
+            <a:off x="7525512" y="2468880"/>
+            <a:ext cx="2011680" cy="3840480"/>
           </a:xfrm>
         </p:spPr>
         <p:txBody>
@@ -18579,8 +18579,8 @@
         </p:nvSpPr>
         <p:spPr>
           <a:xfrm>
-            <a:off x="7315200" y="1508760"/>
-            <a:ext cx="1691640" cy="4983480"/>
+            <a:off x="9756648" y="1508760"/>
+            <a:ext cx="2258568" cy="4983480"/>
           </a:xfrm>
           <a:solidFill>
             <a:srgbClr val="1A2840">
@@ -18619,8 +18619,8 @@
         </p:nvSpPr>
         <p:spPr>
           <a:xfrm>
-            <a:off x="7406640" y="1554480"/>
-            <a:ext cx="1508760" cy="54864"/>
+            <a:off x="9875520" y="1554480"/>
+            <a:ext cx="2011680" cy="54864"/>
           </a:xfrm>
           <a:solidFill>
             <a:srgbClr val="8A9BB0">
@@ -18659,8 +18659,8 @@
         </p:nvSpPr>
         <p:spPr>
           <a:xfrm>
-            <a:off x="7360920" y="1627632"/>
-            <a:ext cx="1600200" cy="292608"/>
+            <a:off x="9820656" y="1627632"/>
+            <a:ext cx="2130552" cy="292608"/>
           </a:xfrm>
         </p:spPr>
         <p:txBody>
@@ -18708,8 +18708,8 @@
         </p:nvSpPr>
         <p:spPr>
           <a:xfrm>
-            <a:off x="7360920" y="1938528"/>
-            <a:ext cx="1600200" cy="457200"/>
+            <a:off x="9820656" y="1938528"/>
+            <a:ext cx="2130552" cy="457200"/>
           </a:xfrm>
         </p:spPr>
         <p:txBody>
@@ -18757,8 +18757,8 @@
         </p:nvSpPr>
         <p:spPr>
           <a:xfrm>
-            <a:off x="7424928" y="2468880"/>
-            <a:ext cx="1508760" cy="3840480"/>
+            <a:off x="9902952" y="2468880"/>
+            <a:ext cx="2011680" cy="3840480"/>
           </a:xfrm>
         </p:spPr>
         <p:txBody>

</xml_diff>